<commit_message>
Presentation v2: shorter, varied layouts, icons; softened framing
Rework the deck to 7 slides with varied layouts (Six/Four Content, Comparison,
Section Header) and representative icons. Benefits framed tangentially (speed,
one source of truth, self-service, control) rather than naming LEAN/waste, and
AI kept in the background — automation does the heavy lifting, people review
and approve.

Co-Authored-By: Claude Opus 4.8 <noreply@anthropic.com>
Claude-Session: https://claude.ai/code/session_01W3gw8scX9B7oMC33JPxjbS
</commit_message>
<xml_diff>
--- a/BioMar_Policy_Library_2026.pptx
+++ b/BioMar_Policy_Library_2026.pptx
@@ -15,11 +15,6 @@
     <p:sldId id="260" r:id="rId17"/>
     <p:sldId id="261" r:id="rId18"/>
     <p:sldId id="262" r:id="rId19"/>
-    <p:sldId id="263" r:id="rId20"/>
-    <p:sldId id="264" r:id="rId21"/>
-    <p:sldId id="265" r:id="rId22"/>
-    <p:sldId id="266" r:id="rId23"/>
-    <p:sldId id="267" r:id="rId24"/>
   </p:sldIdLst>
   <p:sldSz cx="12192000" cy="6858000"/>
   <p:notesSz cx="6858000" cy="9144000"/>
@@ -11530,7 +11525,7 @@
           <a:lstStyle/>
           <a:p>
             <a:r>
-              <a:t>An AI-assisted process for creating, reviewing and publishing policies — faster, leaner, one source of truth</a:t>
+              <a:t>A simpler, faster way to manage policies — the team stays in control</a:t>
             </a:r>
           </a:p>
         </p:txBody>
@@ -11602,390 +11597,6 @@
             <a:extLst>
               <a:ext uri="{FF2B5EF4-FFF2-40B4-BE49-F238E27FC236}">
                 <a16:creationId xmlns:a16="http://schemas.microsoft.com/office/drawing/2014/main" id="{AB0E4FF7-71E0-4C56-80FA-B9721BCB3520}"/>
-              </a:ext>
-            </a:extLst>
-          </p:cNvPr>
-          <p:cNvSpPr>
-            <a:spLocks noGrp="1"/>
-          </p:cNvSpPr>
-          <p:nvPr>
-            <p:ph type="sldNum" sz="quarter" idx="13"/>
-          </p:nvPr>
-        </p:nvSpPr>
-        <p:spPr/>
-        <p:txBody>
-          <a:bodyPr/>
-          <a:lstStyle/>
-          <a:p>
-            <a:fld id="{66F6B9C1-1745-48B0-A8CA-B72E47831159}" type="slidenum">
-              <a:rPr lang="en-GB" noProof="0" smtClean="0"/>
-              <a:pPr/>
-              <a:t>‹#›</a:t>
-            </a:fld>
-            <a:endParaRPr lang="en-GB" noProof="0"/>
-          </a:p>
-        </p:txBody>
-      </p:sp>
-    </p:spTree>
-  </p:cSld>
-  <p:clrMapOvr>
-    <a:masterClrMapping/>
-  </p:clrMapOvr>
-</p:sld>
-</file>
-
-<file path=ppt/slides/slide10.xml><?xml version="1.0" encoding="utf-8"?>
-<p:sld xmlns:a="http://schemas.openxmlformats.org/drawingml/2006/main" xmlns:p="http://schemas.openxmlformats.org/presentationml/2006/main" xmlns:r="http://schemas.openxmlformats.org/officeDocument/2006/relationships">
-  <p:cSld>
-    <p:spTree>
-      <p:nvGrpSpPr>
-        <p:cNvPr id="1" name=""/>
-        <p:cNvGrpSpPr/>
-        <p:nvPr/>
-      </p:nvGrpSpPr>
-      <p:grpSpPr/>
-      <p:sp>
-        <p:nvSpPr>
-          <p:cNvPr id="2" name="Text Placeholder 1"/>
-          <p:cNvSpPr>
-            <a:spLocks noGrp="1"/>
-          </p:cNvSpPr>
-          <p:nvPr>
-            <p:ph type="body" idx="1"/>
-          </p:nvPr>
-        </p:nvSpPr>
-        <p:spPr/>
-        <p:txBody>
-          <a:bodyPr/>
-          <a:lstStyle/>
-          <a:p>
-            <a:r>
-              <a:t>Continuous improvement (Kaizen) — the next steps</a:t>
-            </a:r>
-          </a:p>
-        </p:txBody>
-      </p:sp>
-      <p:sp>
-        <p:nvSpPr>
-          <p:cNvPr id="3" name="Title 2"/>
-          <p:cNvSpPr>
-            <a:spLocks noGrp="1"/>
-          </p:cNvSpPr>
-          <p:nvPr>
-            <p:ph type="title"/>
-          </p:nvPr>
-        </p:nvSpPr>
-        <p:spPr/>
-        <p:txBody>
-          <a:bodyPr/>
-          <a:lstStyle/>
-          <a:p>
-            <a:r>
-              <a:t>How it could improve</a:t>
-            </a:r>
-          </a:p>
-        </p:txBody>
-      </p:sp>
-      <p:sp>
-        <p:nvSpPr>
-          <p:cNvPr id="14" name="Footer Placeholder 13">
-            <a:extLst>
-              <a:ext uri="{FF2B5EF4-FFF2-40B4-BE49-F238E27FC236}">
-                <a16:creationId xmlns:a16="http://schemas.microsoft.com/office/drawing/2014/main" id="{0B69E9C0-49A3-408B-8E81-6900AC6C5CDC}"/>
-              </a:ext>
-            </a:extLst>
-          </p:cNvPr>
-          <p:cNvSpPr>
-            <a:spLocks noGrp="1"/>
-          </p:cNvSpPr>
-          <p:nvPr>
-            <p:ph type="ftr" sz="quarter" idx="11"/>
-          </p:nvPr>
-        </p:nvSpPr>
-        <p:spPr/>
-        <p:txBody>
-          <a:bodyPr/>
-          <a:lstStyle>
-            <a:lvl1pPr>
-              <a:defRPr>
-                <a:solidFill>
-                  <a:schemeClr val="tx1"/>
-                </a:solidFill>
-              </a:defRPr>
-            </a:lvl1pPr>
-          </a:lstStyle>
-          <a:p>
-            <a:r>
-              <a:t>Powered by Partnership. Driven by Innovation.</a:t>
-            </a:r>
-          </a:p>
-        </p:txBody>
-      </p:sp>
-      <p:sp>
-        <p:nvSpPr>
-          <p:cNvPr id="15" name="Slide Number Placeholder 14">
-            <a:extLst>
-              <a:ext uri="{FF2B5EF4-FFF2-40B4-BE49-F238E27FC236}">
-                <a16:creationId xmlns:a16="http://schemas.microsoft.com/office/drawing/2014/main" id="{39CFBA96-2B00-4625-85D6-B57F3F14263B}"/>
-              </a:ext>
-            </a:extLst>
-          </p:cNvPr>
-          <p:cNvSpPr>
-            <a:spLocks noGrp="1"/>
-          </p:cNvSpPr>
-          <p:nvPr>
-            <p:ph type="sldNum" sz="quarter" idx="12"/>
-          </p:nvPr>
-        </p:nvSpPr>
-        <p:spPr/>
-        <p:txBody>
-          <a:bodyPr/>
-          <a:lstStyle/>
-          <a:p>
-            <a:fld id="{66F6B9C1-1745-48B0-A8CA-B72E47831159}" type="slidenum">
-              <a:rPr lang="en-GB" noProof="0" smtClean="0"/>
-              <a:pPr/>
-              <a:t>‹#›</a:t>
-            </a:fld>
-            <a:endParaRPr lang="en-GB" noProof="0"/>
-          </a:p>
-        </p:txBody>
-      </p:sp>
-    </p:spTree>
-  </p:cSld>
-  <p:clrMapOvr>
-    <a:masterClrMapping/>
-  </p:clrMapOvr>
-</p:sld>
-</file>
-
-<file path=ppt/slides/slide11.xml><?xml version="1.0" encoding="utf-8"?>
-<p:sld xmlns:a="http://schemas.openxmlformats.org/drawingml/2006/main" xmlns:p="http://schemas.openxmlformats.org/presentationml/2006/main" xmlns:r="http://schemas.openxmlformats.org/officeDocument/2006/relationships">
-  <p:cSld>
-    <p:spTree>
-      <p:nvGrpSpPr>
-        <p:cNvPr id="1" name=""/>
-        <p:cNvGrpSpPr/>
-        <p:nvPr/>
-      </p:nvGrpSpPr>
-      <p:grpSpPr/>
-      <p:sp>
-        <p:nvSpPr>
-          <p:cNvPr id="2" name="Content Placeholder 1"/>
-          <p:cNvSpPr>
-            <a:spLocks noGrp="1"/>
-          </p:cNvSpPr>
-          <p:nvPr>
-            <p:ph idx="1"/>
-          </p:nvPr>
-        </p:nvSpPr>
-        <p:spPr/>
-        <p:txBody>
-          <a:bodyPr/>
-          <a:lstStyle/>
-          <a:p>
-            <a:pPr/>
-            <a:r>
-              <a:t>Approve &amp; auto-mint the new version from one click, end to end</a:t>
-            </a:r>
-          </a:p>
-          <a:p>
-            <a:pPr/>
-            <a:r>
-              <a:t>Show reviewers a before/after diff of the change</a:t>
-            </a:r>
-          </a:p>
-          <a:p>
-            <a:pPr/>
-            <a:r>
-              <a:t>SLA reminders when a request waits too long</a:t>
-            </a:r>
-          </a:p>
-          <a:p>
-            <a:pPr/>
-            <a:r>
-              <a:t>One-click approve directly from the notification email</a:t>
-            </a:r>
-          </a:p>
-          <a:p>
-            <a:pPr/>
-            <a:r>
-              <a:t>Analytics: cycle time per request, volume, bottlenecks</a:t>
-            </a:r>
-          </a:p>
-          <a:p>
-            <a:pPr/>
-            <a:r>
-              <a:t>Integrations (Teams / Slack) and full-text search across all policies</a:t>
-            </a:r>
-          </a:p>
-        </p:txBody>
-      </p:sp>
-      <p:sp>
-        <p:nvSpPr>
-          <p:cNvPr id="3" name="Title 2"/>
-          <p:cNvSpPr>
-            <a:spLocks noGrp="1"/>
-          </p:cNvSpPr>
-          <p:nvPr>
-            <p:ph type="title"/>
-          </p:nvPr>
-        </p:nvSpPr>
-        <p:spPr/>
-        <p:txBody>
-          <a:bodyPr/>
-          <a:lstStyle/>
-          <a:p>
-            <a:r>
-              <a:t>Roadmap</a:t>
-            </a:r>
-          </a:p>
-        </p:txBody>
-      </p:sp>
-      <p:sp>
-        <p:nvSpPr>
-          <p:cNvPr id="4" name="Footer Placeholder 3">
-            <a:extLst>
-              <a:ext uri="{FF2B5EF4-FFF2-40B4-BE49-F238E27FC236}">
-                <a16:creationId xmlns:a16="http://schemas.microsoft.com/office/drawing/2014/main" id="{37D5DA99-A6A5-4B1D-838D-A53201A41331}"/>
-              </a:ext>
-            </a:extLst>
-          </p:cNvPr>
-          <p:cNvSpPr>
-            <a:spLocks noGrp="1"/>
-          </p:cNvSpPr>
-          <p:nvPr>
-            <p:ph type="ftr" sz="quarter" idx="11"/>
-          </p:nvPr>
-        </p:nvSpPr>
-        <p:spPr/>
-        <p:txBody>
-          <a:bodyPr/>
-          <a:lstStyle/>
-          <a:p>
-            <a:r>
-              <a:t>Powered by Partnership. Driven by Innovation.</a:t>
-            </a:r>
-          </a:p>
-        </p:txBody>
-      </p:sp>
-      <p:sp>
-        <p:nvSpPr>
-          <p:cNvPr id="5" name="Slide Number Placeholder 4">
-            <a:extLst>
-              <a:ext uri="{FF2B5EF4-FFF2-40B4-BE49-F238E27FC236}">
-                <a16:creationId xmlns:a16="http://schemas.microsoft.com/office/drawing/2014/main" id="{CD3E2ED3-B7CA-4509-819E-F58E7A0DAC4F}"/>
-              </a:ext>
-            </a:extLst>
-          </p:cNvPr>
-          <p:cNvSpPr>
-            <a:spLocks noGrp="1"/>
-          </p:cNvSpPr>
-          <p:nvPr>
-            <p:ph type="sldNum" sz="quarter" idx="12"/>
-          </p:nvPr>
-        </p:nvSpPr>
-        <p:spPr/>
-        <p:txBody>
-          <a:bodyPr/>
-          <a:lstStyle/>
-          <a:p>
-            <a:fld id="{66F6B9C1-1745-48B0-A8CA-B72E47831159}" type="slidenum">
-              <a:rPr lang="en-GB" noProof="0" smtClean="0"/>
-              <a:pPr/>
-              <a:t>‹#›</a:t>
-            </a:fld>
-            <a:endParaRPr lang="en-GB" noProof="0"/>
-          </a:p>
-        </p:txBody>
-      </p:sp>
-    </p:spTree>
-  </p:cSld>
-  <p:clrMapOvr>
-    <a:masterClrMapping/>
-  </p:clrMapOvr>
-</p:sld>
-</file>
-
-<file path=ppt/slides/slide12.xml><?xml version="1.0" encoding="utf-8"?>
-<p:sld xmlns:a="http://schemas.openxmlformats.org/drawingml/2006/main" xmlns:p="http://schemas.openxmlformats.org/presentationml/2006/main" xmlns:r="http://schemas.openxmlformats.org/officeDocument/2006/relationships">
-  <p:cSld>
-    <p:spTree>
-      <p:nvGrpSpPr>
-        <p:cNvPr id="1" name=""/>
-        <p:cNvGrpSpPr/>
-        <p:nvPr/>
-      </p:nvGrpSpPr>
-      <p:grpSpPr/>
-      <p:sp>
-        <p:nvSpPr>
-          <p:cNvPr id="2" name="Text Placeholder 1"/>
-          <p:cNvSpPr>
-            <a:spLocks noGrp="1"/>
-          </p:cNvSpPr>
-          <p:nvPr>
-            <p:ph type="body" idx="10" sz="quarter"/>
-          </p:nvPr>
-        </p:nvSpPr>
-        <p:spPr/>
-        <p:txBody>
-          <a:bodyPr/>
-          <a:lstStyle/>
-          <a:p>
-            <a:pPr/>
-            <a:r>
-              <a:t>One process. One source of truth. Minutes, not hours.</a:t>
-            </a:r>
-          </a:p>
-          <a:p>
-            <a:pPr/>
-            <a:r>
-              <a:t>Powered by Partnership. Driven by Innovation.</a:t>
-            </a:r>
-          </a:p>
-        </p:txBody>
-      </p:sp>
-      <p:sp>
-        <p:nvSpPr>
-          <p:cNvPr id="7" name="Footer Placeholder 6">
-            <a:extLst>
-              <a:ext uri="{FF2B5EF4-FFF2-40B4-BE49-F238E27FC236}">
-                <a16:creationId xmlns:a16="http://schemas.microsoft.com/office/drawing/2014/main" id="{BA4B062B-DE74-4D38-82ED-CD55CB311260}"/>
-              </a:ext>
-            </a:extLst>
-          </p:cNvPr>
-          <p:cNvSpPr>
-            <a:spLocks noGrp="1"/>
-          </p:cNvSpPr>
-          <p:nvPr>
-            <p:ph type="ftr" sz="quarter" idx="12"/>
-          </p:nvPr>
-        </p:nvSpPr>
-        <p:spPr/>
-        <p:txBody>
-          <a:bodyPr/>
-          <a:lstStyle>
-            <a:lvl1pPr>
-              <a:defRPr>
-                <a:solidFill>
-                  <a:schemeClr val="accent4"/>
-                </a:solidFill>
-              </a:defRPr>
-            </a:lvl1pPr>
-          </a:lstStyle>
-          <a:p>
-            <a:r>
-              <a:t>Powered by Partnership. Driven by Innovation.</a:t>
-            </a:r>
-          </a:p>
-        </p:txBody>
-      </p:sp>
-      <p:sp>
-        <p:nvSpPr>
-          <p:cNvPr id="8" name="Slide Number Placeholder 7">
-            <a:extLst>
-              <a:ext uri="{FF2B5EF4-FFF2-40B4-BE49-F238E27FC236}">
-                <a16:creationId xmlns:a16="http://schemas.microsoft.com/office/drawing/2014/main" id="{94912303-7C13-44FB-987B-24B3E9030D88}"/>
               </a:ext>
             </a:extLst>
           </p:cNvPr>
@@ -12030,12 +11641,252 @@
       <p:grpSpPr/>
       <p:sp>
         <p:nvSpPr>
-          <p:cNvPr id="2" name="Text Placeholder 1"/>
-          <p:cNvSpPr>
-            <a:spLocks noGrp="1"/>
-          </p:cNvSpPr>
-          <p:nvPr>
-            <p:ph type="body" idx="1"/>
+          <p:cNvPr id="2" name="Content Placeholder 1"/>
+          <p:cNvSpPr>
+            <a:spLocks noGrp="1"/>
+          </p:cNvSpPr>
+          <p:nvPr>
+            <p:ph idx="13" sz="quarter"/>
+          </p:nvPr>
+        </p:nvSpPr>
+        <p:spPr/>
+        <p:txBody>
+          <a:bodyPr wrap="square"/>
+          <a:lstStyle/>
+          <a:p>
+            <a:r>
+              <a:rPr sz="2400"/>
+              <a:t>🧩  </a:t>
+            </a:r>
+            <a:r>
+              <a:rPr sz="1700" b="1">
+                <a:solidFill>
+                  <a:srgbClr val="1C4076"/>
+                </a:solidFill>
+              </a:rPr>
+              <a:t>Disorganised</a:t>
+            </a:r>
+          </a:p>
+          <a:p>
+            <a:r>
+              <a:rPr sz="1300">
+                <a:solidFill>
+                  <a:srgbClr val="6B87A4"/>
+                </a:solidFill>
+              </a:rPr>
+              <a:t>Hard to find the right file</a:t>
+            </a:r>
+          </a:p>
+        </p:txBody>
+      </p:sp>
+      <p:sp>
+        <p:nvSpPr>
+          <p:cNvPr id="3" name="Content Placeholder 2"/>
+          <p:cNvSpPr>
+            <a:spLocks noGrp="1"/>
+          </p:cNvSpPr>
+          <p:nvPr>
+            <p:ph idx="14" sz="quarter"/>
+          </p:nvPr>
+        </p:nvSpPr>
+        <p:spPr/>
+        <p:txBody>
+          <a:bodyPr wrap="square"/>
+          <a:lstStyle/>
+          <a:p>
+            <a:r>
+              <a:rPr sz="2400"/>
+              <a:t>🗂️  </a:t>
+            </a:r>
+            <a:r>
+              <a:rPr sz="1700" b="1">
+                <a:solidFill>
+                  <a:srgbClr val="1C4076"/>
+                </a:solidFill>
+              </a:rPr>
+              <a:t>5+ versions</a:t>
+            </a:r>
+          </a:p>
+          <a:p>
+            <a:r>
+              <a:rPr sz="1300">
+                <a:solidFill>
+                  <a:srgbClr val="6B87A4"/>
+                </a:solidFill>
+              </a:rPr>
+              <a:t>No single source of truth</a:t>
+            </a:r>
+          </a:p>
+        </p:txBody>
+      </p:sp>
+      <p:sp>
+        <p:nvSpPr>
+          <p:cNvPr id="4" name="Content Placeholder 3"/>
+          <p:cNvSpPr>
+            <a:spLocks noGrp="1"/>
+          </p:cNvSpPr>
+          <p:nvPr>
+            <p:ph idx="15" sz="quarter"/>
+          </p:nvPr>
+        </p:nvSpPr>
+        <p:spPr/>
+        <p:txBody>
+          <a:bodyPr wrap="square"/>
+          <a:lstStyle/>
+          <a:p>
+            <a:r>
+              <a:rPr sz="2400"/>
+              <a:t>✉️  </a:t>
+            </a:r>
+            <a:r>
+              <a:rPr sz="1700" b="1">
+                <a:solidFill>
+                  <a:srgbClr val="1C4076"/>
+                </a:solidFill>
+              </a:rPr>
+              <a:t>Email ping-pong</a:t>
+            </a:r>
+          </a:p>
+          <a:p>
+            <a:r>
+              <a:rPr sz="1300">
+                <a:solidFill>
+                  <a:srgbClr val="6B87A4"/>
+                </a:solidFill>
+              </a:rPr>
+              <a:t>Requests lost in threads</a:t>
+            </a:r>
+          </a:p>
+        </p:txBody>
+      </p:sp>
+      <p:sp>
+        <p:nvSpPr>
+          <p:cNvPr id="5" name="Content Placeholder 4"/>
+          <p:cNvSpPr>
+            <a:spLocks noGrp="1"/>
+          </p:cNvSpPr>
+          <p:nvPr>
+            <p:ph idx="16" sz="quarter"/>
+          </p:nvPr>
+        </p:nvSpPr>
+        <p:spPr/>
+        <p:txBody>
+          <a:bodyPr wrap="square"/>
+          <a:lstStyle/>
+          <a:p>
+            <a:r>
+              <a:rPr sz="2400"/>
+              <a:t>❓  </a:t>
+            </a:r>
+            <a:r>
+              <a:rPr sz="1700" b="1">
+                <a:solidFill>
+                  <a:srgbClr val="1C4076"/>
+                </a:solidFill>
+              </a:rPr>
+              <a:t>No clear process</a:t>
+            </a:r>
+          </a:p>
+          <a:p>
+            <a:r>
+              <a:rPr sz="1300">
+                <a:solidFill>
+                  <a:srgbClr val="6B87A4"/>
+                </a:solidFill>
+              </a:rPr>
+              <a:t>Unclear who does what, when</a:t>
+            </a:r>
+          </a:p>
+        </p:txBody>
+      </p:sp>
+      <p:sp>
+        <p:nvSpPr>
+          <p:cNvPr id="6" name="Content Placeholder 5"/>
+          <p:cNvSpPr>
+            <a:spLocks noGrp="1"/>
+          </p:cNvSpPr>
+          <p:nvPr>
+            <p:ph idx="17" sz="quarter"/>
+          </p:nvPr>
+        </p:nvSpPr>
+        <p:spPr/>
+        <p:txBody>
+          <a:bodyPr wrap="square"/>
+          <a:lstStyle/>
+          <a:p>
+            <a:r>
+              <a:rPr sz="2400"/>
+              <a:t>🕒  </a:t>
+            </a:r>
+            <a:r>
+              <a:rPr sz="1700" b="1">
+                <a:solidFill>
+                  <a:srgbClr val="1C4076"/>
+                </a:solidFill>
+              </a:rPr>
+              <a:t>Slow reviews</a:t>
+            </a:r>
+          </a:p>
+          <a:p>
+            <a:r>
+              <a:rPr sz="1300">
+                <a:solidFill>
+                  <a:srgbClr val="6B87A4"/>
+                </a:solidFill>
+              </a:rPr>
+              <a:t>Meetings just to align</a:t>
+            </a:r>
+          </a:p>
+        </p:txBody>
+      </p:sp>
+      <p:sp>
+        <p:nvSpPr>
+          <p:cNvPr id="7" name="Content Placeholder 6"/>
+          <p:cNvSpPr>
+            <a:spLocks noGrp="1"/>
+          </p:cNvSpPr>
+          <p:nvPr>
+            <p:ph idx="18" sz="quarter"/>
+          </p:nvPr>
+        </p:nvSpPr>
+        <p:spPr/>
+        <p:txBody>
+          <a:bodyPr wrap="square"/>
+          <a:lstStyle/>
+          <a:p>
+            <a:r>
+              <a:rPr sz="2400"/>
+              <a:t>⚠️  </a:t>
+            </a:r>
+            <a:r>
+              <a:rPr sz="1700" b="1">
+                <a:solidFill>
+                  <a:srgbClr val="1C4076"/>
+                </a:solidFill>
+              </a:rPr>
+              <a:t>Errors slip through</a:t>
+            </a:r>
+          </a:p>
+          <a:p>
+            <a:r>
+              <a:rPr sz="1300">
+                <a:solidFill>
+                  <a:srgbClr val="6B87A4"/>
+                </a:solidFill>
+              </a:rPr>
+              <a:t>Wrong dates, outdated content</a:t>
+            </a:r>
+          </a:p>
+        </p:txBody>
+      </p:sp>
+      <p:sp>
+        <p:nvSpPr>
+          <p:cNvPr id="8" name="Title 7"/>
+          <p:cNvSpPr>
+            <a:spLocks noGrp="1"/>
+          </p:cNvSpPr>
+          <p:nvPr>
+            <p:ph type="title"/>
           </p:nvPr>
         </p:nvSpPr>
         <p:spPr/>
@@ -12044,19 +11895,25 @@
           <a:lstStyle/>
           <a:p>
             <a:r>
-              <a:t>Why managing policies used to be slow, manual and error-prone</a:t>
-            </a:r>
-          </a:p>
-        </p:txBody>
-      </p:sp>
-      <p:sp>
-        <p:nvSpPr>
-          <p:cNvPr id="3" name="Title 2"/>
-          <p:cNvSpPr>
-            <a:spLocks noGrp="1"/>
-          </p:cNvSpPr>
-          <p:nvPr>
-            <p:ph type="title"/>
+              <a:t>The old way</a:t>
+            </a:r>
+          </a:p>
+        </p:txBody>
+      </p:sp>
+      <p:sp>
+        <p:nvSpPr>
+          <p:cNvPr id="4" name="Footer Placeholder 3">
+            <a:extLst>
+              <a:ext uri="{FF2B5EF4-FFF2-40B4-BE49-F238E27FC236}">
+                <a16:creationId xmlns:a16="http://schemas.microsoft.com/office/drawing/2014/main" id="{70960751-3363-4197-86A3-8617F72DFAD4}"/>
+              </a:ext>
+            </a:extLst>
+          </p:cNvPr>
+          <p:cNvSpPr>
+            <a:spLocks noGrp="1"/>
+          </p:cNvSpPr>
+          <p:nvPr>
+            <p:ph type="ftr" sz="quarter" idx="11"/>
           </p:nvPr>
         </p:nvSpPr>
         <p:spPr/>
@@ -12065,41 +11922,6 @@
           <a:lstStyle/>
           <a:p>
             <a:r>
-              <a:t>The Challenge</a:t>
-            </a:r>
-          </a:p>
-        </p:txBody>
-      </p:sp>
-      <p:sp>
-        <p:nvSpPr>
-          <p:cNvPr id="14" name="Footer Placeholder 13">
-            <a:extLst>
-              <a:ext uri="{FF2B5EF4-FFF2-40B4-BE49-F238E27FC236}">
-                <a16:creationId xmlns:a16="http://schemas.microsoft.com/office/drawing/2014/main" id="{0B69E9C0-49A3-408B-8E81-6900AC6C5CDC}"/>
-              </a:ext>
-            </a:extLst>
-          </p:cNvPr>
-          <p:cNvSpPr>
-            <a:spLocks noGrp="1"/>
-          </p:cNvSpPr>
-          <p:nvPr>
-            <p:ph type="ftr" sz="quarter" idx="11"/>
-          </p:nvPr>
-        </p:nvSpPr>
-        <p:spPr/>
-        <p:txBody>
-          <a:bodyPr/>
-          <a:lstStyle>
-            <a:lvl1pPr>
-              <a:defRPr>
-                <a:solidFill>
-                  <a:schemeClr val="tx1"/>
-                </a:solidFill>
-              </a:defRPr>
-            </a:lvl1pPr>
-          </a:lstStyle>
-          <a:p>
-            <a:r>
               <a:t>Powered by Partnership. Driven by Innovation.</a:t>
             </a:r>
           </a:p>
@@ -12107,10 +11929,10 @@
       </p:sp>
       <p:sp>
         <p:nvSpPr>
-          <p:cNvPr id="15" name="Slide Number Placeholder 14">
-            <a:extLst>
-              <a:ext uri="{FF2B5EF4-FFF2-40B4-BE49-F238E27FC236}">
-                <a16:creationId xmlns:a16="http://schemas.microsoft.com/office/drawing/2014/main" id="{39CFBA96-2B00-4625-85D6-B57F3F14263B}"/>
+          <p:cNvPr id="5" name="Slide Number Placeholder 4">
+            <a:extLst>
+              <a:ext uri="{FF2B5EF4-FFF2-40B4-BE49-F238E27FC236}">
+                <a16:creationId xmlns:a16="http://schemas.microsoft.com/office/drawing/2014/main" id="{5B28ACE3-F4BC-4BB3-975A-583AAA3EA222}"/>
               </a:ext>
             </a:extLst>
           </p:cNvPr>
@@ -12160,7 +11982,167 @@
             <a:spLocks noGrp="1"/>
           </p:cNvSpPr>
           <p:nvPr>
-            <p:ph idx="1"/>
+            <p:ph idx="1" sz="half"/>
+          </p:nvPr>
+        </p:nvSpPr>
+        <p:spPr/>
+        <p:txBody>
+          <a:bodyPr wrap="square"/>
+          <a:lstStyle/>
+          <a:p>
+            <a:r>
+              <a:rPr sz="2400"/>
+              <a:t>📥  </a:t>
+            </a:r>
+            <a:r>
+              <a:rPr sz="1700" b="1">
+                <a:solidFill>
+                  <a:srgbClr val="1C4076"/>
+                </a:solidFill>
+              </a:rPr>
+              <a:t>1 · Request</a:t>
+            </a:r>
+          </a:p>
+          <a:p>
+            <a:r>
+              <a:rPr sz="1300">
+                <a:solidFill>
+                  <a:srgbClr val="6B87A4"/>
+                </a:solidFill>
+              </a:rPr>
+              <a:t>Ask for a change or a new policy — pick the version you need</a:t>
+            </a:r>
+          </a:p>
+        </p:txBody>
+      </p:sp>
+      <p:sp>
+        <p:nvSpPr>
+          <p:cNvPr id="3" name="Content Placeholder 2"/>
+          <p:cNvSpPr>
+            <a:spLocks noGrp="1"/>
+          </p:cNvSpPr>
+          <p:nvPr>
+            <p:ph idx="13" sz="half"/>
+          </p:nvPr>
+        </p:nvSpPr>
+        <p:spPr/>
+        <p:txBody>
+          <a:bodyPr wrap="square"/>
+          <a:lstStyle/>
+          <a:p>
+            <a:r>
+              <a:rPr sz="2400"/>
+              <a:t>✍️  </a:t>
+            </a:r>
+            <a:r>
+              <a:rPr sz="1700" b="1">
+                <a:solidFill>
+                  <a:srgbClr val="1C4076"/>
+                </a:solidFill>
+              </a:rPr>
+              <a:t>3 · Review</a:t>
+            </a:r>
+          </a:p>
+          <a:p>
+            <a:r>
+              <a:rPr sz="1300">
+                <a:solidFill>
+                  <a:srgbClr val="6B87A4"/>
+                </a:solidFill>
+              </a:rPr>
+              <a:t>People highlight, comment and decide — nothing ships without review</a:t>
+            </a:r>
+          </a:p>
+        </p:txBody>
+      </p:sp>
+      <p:sp>
+        <p:nvSpPr>
+          <p:cNvPr id="4" name="Content Placeholder 3"/>
+          <p:cNvSpPr>
+            <a:spLocks noGrp="1"/>
+          </p:cNvSpPr>
+          <p:nvPr>
+            <p:ph idx="14" sz="half"/>
+          </p:nvPr>
+        </p:nvSpPr>
+        <p:spPr/>
+        <p:txBody>
+          <a:bodyPr wrap="square"/>
+          <a:lstStyle/>
+          <a:p>
+            <a:r>
+              <a:rPr sz="2400"/>
+              <a:t>🎨  </a:t>
+            </a:r>
+            <a:r>
+              <a:rPr sz="1700" b="1">
+                <a:solidFill>
+                  <a:srgbClr val="1C4076"/>
+                </a:solidFill>
+              </a:rPr>
+              <a:t>2 · Auto-format</a:t>
+            </a:r>
+          </a:p>
+          <a:p>
+            <a:r>
+              <a:rPr sz="1300">
+                <a:solidFill>
+                  <a:srgbClr val="6B87A4"/>
+                </a:solidFill>
+              </a:rPr>
+              <a:t>The BioMar template is applied for you, instantly → PDF + editable Word</a:t>
+            </a:r>
+          </a:p>
+        </p:txBody>
+      </p:sp>
+      <p:sp>
+        <p:nvSpPr>
+          <p:cNvPr id="5" name="Content Placeholder 4"/>
+          <p:cNvSpPr>
+            <a:spLocks noGrp="1"/>
+          </p:cNvSpPr>
+          <p:nvPr>
+            <p:ph idx="15" sz="half"/>
+          </p:nvPr>
+        </p:nvSpPr>
+        <p:spPr/>
+        <p:txBody>
+          <a:bodyPr wrap="square"/>
+          <a:lstStyle/>
+          <a:p>
+            <a:r>
+              <a:rPr sz="2400"/>
+              <a:t>✅  </a:t>
+            </a:r>
+            <a:r>
+              <a:rPr sz="1700" b="1">
+                <a:solidFill>
+                  <a:srgbClr val="1C4076"/>
+                </a:solidFill>
+              </a:rPr>
+              <a:t>4 · Approve &amp; publish</a:t>
+            </a:r>
+          </a:p>
+          <a:p>
+            <a:r>
+              <a:rPr sz="1300">
+                <a:solidFill>
+                  <a:srgbClr val="6B87A4"/>
+                </a:solidFill>
+              </a:rPr>
+              <a:t>The team approves; the version is published and kept</a:t>
+            </a:r>
+          </a:p>
+        </p:txBody>
+      </p:sp>
+      <p:sp>
+        <p:nvSpPr>
+          <p:cNvPr id="6" name="Title 5"/>
+          <p:cNvSpPr>
+            <a:spLocks noGrp="1"/>
+          </p:cNvSpPr>
+          <p:nvPr>
+            <p:ph type="title"/>
           </p:nvPr>
         </p:nvSpPr>
         <p:spPr/>
@@ -12168,51 +12150,26 @@
           <a:bodyPr/>
           <a:lstStyle/>
           <a:p>
-            <a:pPr/>
-            <a:r>
-              <a:t>Manual reformatting of every policy into the BioMar template</a:t>
-            </a:r>
-          </a:p>
-          <a:p>
-            <a:pPr/>
-            <a:r>
-              <a:t>5+ scattered versions — no single source of truth</a:t>
-            </a:r>
-          </a:p>
-          <a:p>
-            <a:pPr/>
-            <a:r>
-              <a:t>Change requests by email → endless back-and-forth, lost context</a:t>
-            </a:r>
-          </a:p>
-          <a:p>
-            <a:pPr/>
-            <a:r>
-              <a:t>No clear process and no visibility of status</a:t>
-            </a:r>
-          </a:p>
-          <a:p>
-            <a:pPr/>
-            <a:r>
-              <a:t>Slow, unnecessary review meetings</a:t>
-            </a:r>
-          </a:p>
-          <a:p>
-            <a:pPr/>
-            <a:r>
-              <a:t>Errors: dropped content, wrong approval dates, outdated approvers</a:t>
-            </a:r>
-          </a:p>
-        </p:txBody>
-      </p:sp>
-      <p:sp>
-        <p:nvSpPr>
-          <p:cNvPr id="3" name="Title 2"/>
-          <p:cNvSpPr>
-            <a:spLocks noGrp="1"/>
-          </p:cNvSpPr>
-          <p:nvPr>
-            <p:ph type="title"/>
+            <a:r>
+              <a:t>One clear flow</a:t>
+            </a:r>
+          </a:p>
+        </p:txBody>
+      </p:sp>
+      <p:sp>
+        <p:nvSpPr>
+          <p:cNvPr id="6" name="Footer Placeholder 5">
+            <a:extLst>
+              <a:ext uri="{FF2B5EF4-FFF2-40B4-BE49-F238E27FC236}">
+                <a16:creationId xmlns:a16="http://schemas.microsoft.com/office/drawing/2014/main" id="{50152516-C652-40E0-A0E5-B9ADA7B8AF97}"/>
+              </a:ext>
+            </a:extLst>
+          </p:cNvPr>
+          <p:cNvSpPr>
+            <a:spLocks noGrp="1"/>
+          </p:cNvSpPr>
+          <p:nvPr>
+            <p:ph type="ftr" sz="quarter" idx="17"/>
           </p:nvPr>
         </p:nvSpPr>
         <p:spPr/>
@@ -12221,33 +12178,6 @@
           <a:lstStyle/>
           <a:p>
             <a:r>
-              <a:t>Challenges — the old way</a:t>
-            </a:r>
-          </a:p>
-        </p:txBody>
-      </p:sp>
-      <p:sp>
-        <p:nvSpPr>
-          <p:cNvPr id="4" name="Footer Placeholder 3">
-            <a:extLst>
-              <a:ext uri="{FF2B5EF4-FFF2-40B4-BE49-F238E27FC236}">
-                <a16:creationId xmlns:a16="http://schemas.microsoft.com/office/drawing/2014/main" id="{37D5DA99-A6A5-4B1D-838D-A53201A41331}"/>
-              </a:ext>
-            </a:extLst>
-          </p:cNvPr>
-          <p:cNvSpPr>
-            <a:spLocks noGrp="1"/>
-          </p:cNvSpPr>
-          <p:nvPr>
-            <p:ph type="ftr" sz="quarter" idx="11"/>
-          </p:nvPr>
-        </p:nvSpPr>
-        <p:spPr/>
-        <p:txBody>
-          <a:bodyPr/>
-          <a:lstStyle/>
-          <a:p>
-            <a:r>
               <a:t>Powered by Partnership. Driven by Innovation.</a:t>
             </a:r>
           </a:p>
@@ -12255,18 +12185,18 @@
       </p:sp>
       <p:sp>
         <p:nvSpPr>
-          <p:cNvPr id="5" name="Slide Number Placeholder 4">
-            <a:extLst>
-              <a:ext uri="{FF2B5EF4-FFF2-40B4-BE49-F238E27FC236}">
-                <a16:creationId xmlns:a16="http://schemas.microsoft.com/office/drawing/2014/main" id="{CD3E2ED3-B7CA-4509-819E-F58E7A0DAC4F}"/>
-              </a:ext>
-            </a:extLst>
-          </p:cNvPr>
-          <p:cNvSpPr>
-            <a:spLocks noGrp="1"/>
-          </p:cNvSpPr>
-          <p:nvPr>
-            <p:ph type="sldNum" sz="quarter" idx="12"/>
+          <p:cNvPr id="7" name="Slide Number Placeholder 6">
+            <a:extLst>
+              <a:ext uri="{FF2B5EF4-FFF2-40B4-BE49-F238E27FC236}">
+                <a16:creationId xmlns:a16="http://schemas.microsoft.com/office/drawing/2014/main" id="{42E6685B-740F-4E4A-90C9-64331236C977}"/>
+              </a:ext>
+            </a:extLst>
+          </p:cNvPr>
+          <p:cNvSpPr>
+            <a:spLocks noGrp="1"/>
+          </p:cNvSpPr>
+          <p:nvPr>
+            <p:ph type="sldNum" sz="quarter" idx="18"/>
           </p:nvPr>
         </p:nvSpPr>
         <p:spPr/>
@@ -12317,19 +12247,19 @@
           <a:lstStyle/>
           <a:p>
             <a:r>
-              <a:t>One flow, end to end — from request to published version</a:t>
-            </a:r>
-          </a:p>
-        </p:txBody>
-      </p:sp>
-      <p:sp>
-        <p:nvSpPr>
-          <p:cNvPr id="3" name="Title 2"/>
-          <p:cNvSpPr>
-            <a:spLocks noGrp="1"/>
-          </p:cNvSpPr>
-          <p:nvPr>
-            <p:ph type="title"/>
+              <a:t>🐌  Before</a:t>
+            </a:r>
+          </a:p>
+        </p:txBody>
+      </p:sp>
+      <p:sp>
+        <p:nvSpPr>
+          <p:cNvPr id="3" name="Content Placeholder 2"/>
+          <p:cNvSpPr>
+            <a:spLocks noGrp="1"/>
+          </p:cNvSpPr>
+          <p:nvPr>
+            <p:ph idx="2" sz="half"/>
           </p:nvPr>
         </p:nvSpPr>
         <p:spPr/>
@@ -12337,40 +12267,133 @@
           <a:bodyPr/>
           <a:lstStyle/>
           <a:p>
-            <a:r>
-              <a:t>The Process</a:t>
-            </a:r>
-          </a:p>
-        </p:txBody>
-      </p:sp>
-      <p:sp>
-        <p:nvSpPr>
-          <p:cNvPr id="14" name="Footer Placeholder 13">
-            <a:extLst>
-              <a:ext uri="{FF2B5EF4-FFF2-40B4-BE49-F238E27FC236}">
-                <a16:creationId xmlns:a16="http://schemas.microsoft.com/office/drawing/2014/main" id="{0B69E9C0-49A3-408B-8E81-6900AC6C5CDC}"/>
-              </a:ext>
-            </a:extLst>
-          </p:cNvPr>
-          <p:cNvSpPr>
-            <a:spLocks noGrp="1"/>
-          </p:cNvSpPr>
-          <p:nvPr>
-            <p:ph type="ftr" sz="quarter" idx="11"/>
+            <a:pPr/>
+            <a:r>
+              <a:t>Hours of manual reformatting</a:t>
+            </a:r>
+          </a:p>
+          <a:p>
+            <a:pPr/>
+            <a:r>
+              <a:t>Versions scattered everywhere</a:t>
+            </a:r>
+          </a:p>
+          <a:p>
+            <a:pPr/>
+            <a:r>
+              <a:t>Status invisible, chased by email</a:t>
+            </a:r>
+          </a:p>
+          <a:p>
+            <a:pPr/>
+            <a:r>
+              <a:t>No reliable history</a:t>
+            </a:r>
+          </a:p>
+        </p:txBody>
+      </p:sp>
+      <p:sp>
+        <p:nvSpPr>
+          <p:cNvPr id="4" name="Text Placeholder 3"/>
+          <p:cNvSpPr>
+            <a:spLocks noGrp="1"/>
+          </p:cNvSpPr>
+          <p:nvPr>
+            <p:ph type="body" idx="3" sz="quarter"/>
           </p:nvPr>
         </p:nvSpPr>
         <p:spPr/>
         <p:txBody>
           <a:bodyPr/>
-          <a:lstStyle>
-            <a:lvl1pPr>
-              <a:defRPr>
-                <a:solidFill>
-                  <a:schemeClr val="tx1"/>
-                </a:solidFill>
-              </a:defRPr>
-            </a:lvl1pPr>
-          </a:lstStyle>
+          <a:lstStyle/>
+          <a:p>
+            <a:r>
+              <a:t>⚡  After</a:t>
+            </a:r>
+          </a:p>
+        </p:txBody>
+      </p:sp>
+      <p:sp>
+        <p:nvSpPr>
+          <p:cNvPr id="5" name="Content Placeholder 4"/>
+          <p:cNvSpPr>
+            <a:spLocks noGrp="1"/>
+          </p:cNvSpPr>
+          <p:nvPr>
+            <p:ph idx="13" sz="half"/>
+          </p:nvPr>
+        </p:nvSpPr>
+        <p:spPr/>
+        <p:txBody>
+          <a:bodyPr/>
+          <a:lstStyle/>
+          <a:p>
+            <a:pPr/>
+            <a:r>
+              <a:t>Branded PDF + Word in minutes</a:t>
+            </a:r>
+          </a:p>
+          <a:p>
+            <a:pPr/>
+            <a:r>
+              <a:t>One place, one source of truth</a:t>
+            </a:r>
+          </a:p>
+          <a:p>
+            <a:pPr/>
+            <a:r>
+              <a:t>Live status on a dashboard</a:t>
+            </a:r>
+          </a:p>
+          <a:p>
+            <a:pPr/>
+            <a:r>
+              <a:t>Full history: who asked &amp; approved</a:t>
+            </a:r>
+          </a:p>
+        </p:txBody>
+      </p:sp>
+      <p:sp>
+        <p:nvSpPr>
+          <p:cNvPr id="6" name="Title 5"/>
+          <p:cNvSpPr>
+            <a:spLocks noGrp="1"/>
+          </p:cNvSpPr>
+          <p:nvPr>
+            <p:ph type="title"/>
+          </p:nvPr>
+        </p:nvSpPr>
+        <p:spPr/>
+        <p:txBody>
+          <a:bodyPr/>
+          <a:lstStyle/>
+          <a:p>
+            <a:r>
+              <a:t>Before  →  After</a:t>
+            </a:r>
+          </a:p>
+        </p:txBody>
+      </p:sp>
+      <p:sp>
+        <p:nvSpPr>
+          <p:cNvPr id="18" name="Footer Placeholder 17">
+            <a:extLst>
+              <a:ext uri="{FF2B5EF4-FFF2-40B4-BE49-F238E27FC236}">
+                <a16:creationId xmlns:a16="http://schemas.microsoft.com/office/drawing/2014/main" id="{78C02DC0-1D54-4077-A3AE-CE6AE7382049}"/>
+              </a:ext>
+            </a:extLst>
+          </p:cNvPr>
+          <p:cNvSpPr>
+            <a:spLocks noGrp="1"/>
+          </p:cNvSpPr>
+          <p:nvPr>
+            <p:ph type="ftr" sz="quarter" idx="15"/>
+          </p:nvPr>
+        </p:nvSpPr>
+        <p:spPr/>
+        <p:txBody>
+          <a:bodyPr/>
+          <a:lstStyle/>
           <a:p>
             <a:r>
               <a:t>Powered by Partnership. Driven by Innovation.</a:t>
@@ -12380,18 +12403,18 @@
       </p:sp>
       <p:sp>
         <p:nvSpPr>
-          <p:cNvPr id="15" name="Slide Number Placeholder 14">
-            <a:extLst>
-              <a:ext uri="{FF2B5EF4-FFF2-40B4-BE49-F238E27FC236}">
-                <a16:creationId xmlns:a16="http://schemas.microsoft.com/office/drawing/2014/main" id="{39CFBA96-2B00-4625-85D6-B57F3F14263B}"/>
-              </a:ext>
-            </a:extLst>
-          </p:cNvPr>
-          <p:cNvSpPr>
-            <a:spLocks noGrp="1"/>
-          </p:cNvSpPr>
-          <p:nvPr>
-            <p:ph type="sldNum" sz="quarter" idx="12"/>
+          <p:cNvPr id="19" name="Slide Number Placeholder 18">
+            <a:extLst>
+              <a:ext uri="{FF2B5EF4-FFF2-40B4-BE49-F238E27FC236}">
+                <a16:creationId xmlns:a16="http://schemas.microsoft.com/office/drawing/2014/main" id="{C30F974C-5E8C-48FE-9EBF-6D61C4ACCDF7}"/>
+              </a:ext>
+            </a:extLst>
+          </p:cNvPr>
+          <p:cNvSpPr>
+            <a:spLocks noGrp="1"/>
+          </p:cNvSpPr>
+          <p:nvPr>
+            <p:ph type="sldNum" sz="quarter" idx="16"/>
           </p:nvPr>
         </p:nvSpPr>
         <p:spPr/>
@@ -12433,7 +12456,167 @@
             <a:spLocks noGrp="1"/>
           </p:cNvSpPr>
           <p:nvPr>
-            <p:ph idx="1"/>
+            <p:ph idx="1" sz="half"/>
+          </p:nvPr>
+        </p:nvSpPr>
+        <p:spPr/>
+        <p:txBody>
+          <a:bodyPr wrap="square"/>
+          <a:lstStyle/>
+          <a:p>
+            <a:r>
+              <a:rPr sz="2400"/>
+              <a:t>⚡  </a:t>
+            </a:r>
+            <a:r>
+              <a:rPr sz="1700" b="1">
+                <a:solidFill>
+                  <a:srgbClr val="1C4076"/>
+                </a:solidFill>
+              </a:rPr>
+              <a:t>Minutes, not hours</a:t>
+            </a:r>
+          </a:p>
+          <a:p>
+            <a:r>
+              <a:rPr sz="1300">
+                <a:solidFill>
+                  <a:srgbClr val="6B87A4"/>
+                </a:solidFill>
+              </a:rPr>
+              <a:t>Branded documents produced automatically</a:t>
+            </a:r>
+          </a:p>
+        </p:txBody>
+      </p:sp>
+      <p:sp>
+        <p:nvSpPr>
+          <p:cNvPr id="3" name="Content Placeholder 2"/>
+          <p:cNvSpPr>
+            <a:spLocks noGrp="1"/>
+          </p:cNvSpPr>
+          <p:nvPr>
+            <p:ph idx="13" sz="half"/>
+          </p:nvPr>
+        </p:nvSpPr>
+        <p:spPr/>
+        <p:txBody>
+          <a:bodyPr wrap="square"/>
+          <a:lstStyle/>
+          <a:p>
+            <a:r>
+              <a:rPr sz="2400"/>
+              <a:t>🙌  </a:t>
+            </a:r>
+            <a:r>
+              <a:rPr sz="1700" b="1">
+                <a:solidFill>
+                  <a:srgbClr val="1C4076"/>
+                </a:solidFill>
+              </a:rPr>
+              <a:t>Self-service</a:t>
+            </a:r>
+          </a:p>
+          <a:p>
+            <a:r>
+              <a:rPr sz="1300">
+                <a:solidFill>
+                  <a:srgbClr val="6B87A4"/>
+                </a:solidFill>
+              </a:rPr>
+              <a:t>Request and track without chasing anyone</a:t>
+            </a:r>
+          </a:p>
+        </p:txBody>
+      </p:sp>
+      <p:sp>
+        <p:nvSpPr>
+          <p:cNvPr id="4" name="Content Placeholder 3"/>
+          <p:cNvSpPr>
+            <a:spLocks noGrp="1"/>
+          </p:cNvSpPr>
+          <p:nvPr>
+            <p:ph idx="14" sz="half"/>
+          </p:nvPr>
+        </p:nvSpPr>
+        <p:spPr/>
+        <p:txBody>
+          <a:bodyPr wrap="square"/>
+          <a:lstStyle/>
+          <a:p>
+            <a:r>
+              <a:rPr sz="2400"/>
+              <a:t>📌  </a:t>
+            </a:r>
+            <a:r>
+              <a:rPr sz="1700" b="1">
+                <a:solidFill>
+                  <a:srgbClr val="1C4076"/>
+                </a:solidFill>
+              </a:rPr>
+              <a:t>One source of truth</a:t>
+            </a:r>
+          </a:p>
+          <a:p>
+            <a:r>
+              <a:rPr sz="1300">
+                <a:solidFill>
+                  <a:srgbClr val="6B87A4"/>
+                </a:solidFill>
+              </a:rPr>
+              <a:t>Always the current version, nothing scattered</a:t>
+            </a:r>
+          </a:p>
+        </p:txBody>
+      </p:sp>
+      <p:sp>
+        <p:nvSpPr>
+          <p:cNvPr id="5" name="Content Placeholder 4"/>
+          <p:cNvSpPr>
+            <a:spLocks noGrp="1"/>
+          </p:cNvSpPr>
+          <p:nvPr>
+            <p:ph idx="15" sz="half"/>
+          </p:nvPr>
+        </p:nvSpPr>
+        <p:spPr/>
+        <p:txBody>
+          <a:bodyPr wrap="square"/>
+          <a:lstStyle/>
+          <a:p>
+            <a:r>
+              <a:rPr sz="2400"/>
+              <a:t>🛡️  </a:t>
+            </a:r>
+            <a:r>
+              <a:rPr sz="1700" b="1">
+                <a:solidFill>
+                  <a:srgbClr val="1C4076"/>
+                </a:solidFill>
+              </a:rPr>
+              <a:t>You stay in control</a:t>
+            </a:r>
+          </a:p>
+          <a:p>
+            <a:r>
+              <a:rPr sz="1300">
+                <a:solidFill>
+                  <a:srgbClr val="6B87A4"/>
+                </a:solidFill>
+              </a:rPr>
+              <a:t>Every version is reviewed and approved by the team</a:t>
+            </a:r>
+          </a:p>
+        </p:txBody>
+      </p:sp>
+      <p:sp>
+        <p:nvSpPr>
+          <p:cNvPr id="6" name="Title 5"/>
+          <p:cNvSpPr>
+            <a:spLocks noGrp="1"/>
+          </p:cNvSpPr>
+          <p:nvPr>
+            <p:ph type="title"/>
           </p:nvPr>
         </p:nvSpPr>
         <p:spPr/>
@@ -12441,51 +12624,26 @@
           <a:bodyPr/>
           <a:lstStyle/>
           <a:p>
-            <a:pPr/>
-            <a:r>
-              <a:t>1 · Request — a user asks for a change or a new policy (chooses Signed / Unsigned / Both)</a:t>
-            </a:r>
-          </a:p>
-          <a:p>
-            <a:pPr/>
-            <a:r>
-              <a:t>2 · Format — the AI applies the BioMar template automatically → branded PDF + editable Word</a:t>
-            </a:r>
-          </a:p>
-          <a:p>
-            <a:pPr/>
-            <a:r>
-              <a:t>3 · Review — highlight the live PDF, comment and attach files, all in one place</a:t>
-            </a:r>
-          </a:p>
-          <a:p>
-            <a:pPr/>
-            <a:r>
-              <a:t>4 · Notify — the requester is emailed automatically the moment it is ready</a:t>
-            </a:r>
-          </a:p>
-          <a:p>
-            <a:pPr/>
-            <a:r>
-              <a:t>5 · Approve — one click; the previous version is frozen and preserved</a:t>
-            </a:r>
-          </a:p>
-          <a:p>
-            <a:pPr/>
-            <a:r>
-              <a:t>6 · Publish — versioned PDF + Word go live in the library, with full history</a:t>
-            </a:r>
-          </a:p>
-        </p:txBody>
-      </p:sp>
-      <p:sp>
-        <p:nvSpPr>
-          <p:cNvPr id="3" name="Title 2"/>
-          <p:cNvSpPr>
-            <a:spLocks noGrp="1"/>
-          </p:cNvSpPr>
-          <p:nvPr>
-            <p:ph type="title"/>
+            <a:r>
+              <a:t>What changes for you</a:t>
+            </a:r>
+          </a:p>
+        </p:txBody>
+      </p:sp>
+      <p:sp>
+        <p:nvSpPr>
+          <p:cNvPr id="6" name="Footer Placeholder 5">
+            <a:extLst>
+              <a:ext uri="{FF2B5EF4-FFF2-40B4-BE49-F238E27FC236}">
+                <a16:creationId xmlns:a16="http://schemas.microsoft.com/office/drawing/2014/main" id="{50152516-C652-40E0-A0E5-B9ADA7B8AF97}"/>
+              </a:ext>
+            </a:extLst>
+          </p:cNvPr>
+          <p:cNvSpPr>
+            <a:spLocks noGrp="1"/>
+          </p:cNvSpPr>
+          <p:nvPr>
+            <p:ph type="ftr" sz="quarter" idx="17"/>
           </p:nvPr>
         </p:nvSpPr>
         <p:spPr/>
@@ -12494,33 +12652,6 @@
           <a:lstStyle/>
           <a:p>
             <a:r>
-              <a:t>The end-to-end flow</a:t>
-            </a:r>
-          </a:p>
-        </p:txBody>
-      </p:sp>
-      <p:sp>
-        <p:nvSpPr>
-          <p:cNvPr id="4" name="Footer Placeholder 3">
-            <a:extLst>
-              <a:ext uri="{FF2B5EF4-FFF2-40B4-BE49-F238E27FC236}">
-                <a16:creationId xmlns:a16="http://schemas.microsoft.com/office/drawing/2014/main" id="{37D5DA99-A6A5-4B1D-838D-A53201A41331}"/>
-              </a:ext>
-            </a:extLst>
-          </p:cNvPr>
-          <p:cNvSpPr>
-            <a:spLocks noGrp="1"/>
-          </p:cNvSpPr>
-          <p:nvPr>
-            <p:ph type="ftr" sz="quarter" idx="11"/>
-          </p:nvPr>
-        </p:nvSpPr>
-        <p:spPr/>
-        <p:txBody>
-          <a:bodyPr/>
-          <a:lstStyle/>
-          <a:p>
-            <a:r>
               <a:t>Powered by Partnership. Driven by Innovation.</a:t>
             </a:r>
           </a:p>
@@ -12528,18 +12659,18 @@
       </p:sp>
       <p:sp>
         <p:nvSpPr>
-          <p:cNvPr id="5" name="Slide Number Placeholder 4">
-            <a:extLst>
-              <a:ext uri="{FF2B5EF4-FFF2-40B4-BE49-F238E27FC236}">
-                <a16:creationId xmlns:a16="http://schemas.microsoft.com/office/drawing/2014/main" id="{CD3E2ED3-B7CA-4509-819E-F58E7A0DAC4F}"/>
-              </a:ext>
-            </a:extLst>
-          </p:cNvPr>
-          <p:cNvSpPr>
-            <a:spLocks noGrp="1"/>
-          </p:cNvSpPr>
-          <p:nvPr>
-            <p:ph type="sldNum" sz="quarter" idx="12"/>
+          <p:cNvPr id="7" name="Slide Number Placeholder 6">
+            <a:extLst>
+              <a:ext uri="{FF2B5EF4-FFF2-40B4-BE49-F238E27FC236}">
+                <a16:creationId xmlns:a16="http://schemas.microsoft.com/office/drawing/2014/main" id="{42E6685B-740F-4E4A-90C9-64331236C977}"/>
+              </a:ext>
+            </a:extLst>
+          </p:cNvPr>
+          <p:cNvSpPr>
+            <a:spLocks noGrp="1"/>
+          </p:cNvSpPr>
+          <p:nvPr>
+            <p:ph type="sldNum" sz="quarter" idx="18"/>
           </p:nvPr>
         </p:nvSpPr>
         <p:spPr/>
@@ -12576,12 +12707,172 @@
       <p:grpSpPr/>
       <p:sp>
         <p:nvSpPr>
-          <p:cNvPr id="2" name="Text Placeholder 1"/>
-          <p:cNvSpPr>
-            <a:spLocks noGrp="1"/>
-          </p:cNvSpPr>
-          <p:nvPr>
-            <p:ph type="body" idx="1"/>
+          <p:cNvPr id="2" name="Content Placeholder 1"/>
+          <p:cNvSpPr>
+            <a:spLocks noGrp="1"/>
+          </p:cNvSpPr>
+          <p:nvPr>
+            <p:ph idx="1" sz="half"/>
+          </p:nvPr>
+        </p:nvSpPr>
+        <p:spPr/>
+        <p:txBody>
+          <a:bodyPr wrap="square"/>
+          <a:lstStyle/>
+          <a:p>
+            <a:r>
+              <a:rPr sz="2400"/>
+              <a:t>🔁  </a:t>
+            </a:r>
+            <a:r>
+              <a:rPr sz="1700" b="1">
+                <a:solidFill>
+                  <a:srgbClr val="1C4076"/>
+                </a:solidFill>
+              </a:rPr>
+              <a:t>One-click approve</a:t>
+            </a:r>
+          </a:p>
+          <a:p>
+            <a:r>
+              <a:rPr sz="1300">
+                <a:solidFill>
+                  <a:srgbClr val="6B87A4"/>
+                </a:solidFill>
+              </a:rPr>
+              <a:t>Approve and publish the new version end to end</a:t>
+            </a:r>
+          </a:p>
+        </p:txBody>
+      </p:sp>
+      <p:sp>
+        <p:nvSpPr>
+          <p:cNvPr id="3" name="Content Placeholder 2"/>
+          <p:cNvSpPr>
+            <a:spLocks noGrp="1"/>
+          </p:cNvSpPr>
+          <p:nvPr>
+            <p:ph idx="13" sz="half"/>
+          </p:nvPr>
+        </p:nvSpPr>
+        <p:spPr/>
+        <p:txBody>
+          <a:bodyPr wrap="square"/>
+          <a:lstStyle/>
+          <a:p>
+            <a:r>
+              <a:rPr sz="2400"/>
+              <a:t>🔔  </a:t>
+            </a:r>
+            <a:r>
+              <a:rPr sz="1700" b="1">
+                <a:solidFill>
+                  <a:srgbClr val="1C4076"/>
+                </a:solidFill>
+              </a:rPr>
+              <a:t>Gentle reminders</a:t>
+            </a:r>
+          </a:p>
+          <a:p>
+            <a:r>
+              <a:rPr sz="1300">
+                <a:solidFill>
+                  <a:srgbClr val="6B87A4"/>
+                </a:solidFill>
+              </a:rPr>
+              <a:t>Nudges when something waits too long</a:t>
+            </a:r>
+          </a:p>
+        </p:txBody>
+      </p:sp>
+      <p:sp>
+        <p:nvSpPr>
+          <p:cNvPr id="4" name="Content Placeholder 3"/>
+          <p:cNvSpPr>
+            <a:spLocks noGrp="1"/>
+          </p:cNvSpPr>
+          <p:nvPr>
+            <p:ph idx="14" sz="half"/>
+          </p:nvPr>
+        </p:nvSpPr>
+        <p:spPr/>
+        <p:txBody>
+          <a:bodyPr wrap="square"/>
+          <a:lstStyle/>
+          <a:p>
+            <a:r>
+              <a:rPr sz="2400"/>
+              <a:t>🔍  </a:t>
+            </a:r>
+            <a:r>
+              <a:rPr sz="1700" b="1">
+                <a:solidFill>
+                  <a:srgbClr val="1C4076"/>
+                </a:solidFill>
+              </a:rPr>
+              <a:t>See the change</a:t>
+            </a:r>
+          </a:p>
+          <a:p>
+            <a:r>
+              <a:rPr sz="1300">
+                <a:solidFill>
+                  <a:srgbClr val="6B87A4"/>
+                </a:solidFill>
+              </a:rPr>
+              <a:t>A clear before/after for every review</a:t>
+            </a:r>
+          </a:p>
+        </p:txBody>
+      </p:sp>
+      <p:sp>
+        <p:nvSpPr>
+          <p:cNvPr id="5" name="Content Placeholder 4"/>
+          <p:cNvSpPr>
+            <a:spLocks noGrp="1"/>
+          </p:cNvSpPr>
+          <p:nvPr>
+            <p:ph idx="15" sz="half"/>
+          </p:nvPr>
+        </p:nvSpPr>
+        <p:spPr/>
+        <p:txBody>
+          <a:bodyPr wrap="square"/>
+          <a:lstStyle/>
+          <a:p>
+            <a:r>
+              <a:rPr sz="2400"/>
+              <a:t>📊  </a:t>
+            </a:r>
+            <a:r>
+              <a:rPr sz="1700" b="1">
+                <a:solidFill>
+                  <a:srgbClr val="1C4076"/>
+                </a:solidFill>
+              </a:rPr>
+              <a:t>Insight</a:t>
+            </a:r>
+          </a:p>
+          <a:p>
+            <a:r>
+              <a:rPr sz="1300">
+                <a:solidFill>
+                  <a:srgbClr val="6B87A4"/>
+                </a:solidFill>
+              </a:rPr>
+              <a:t>Turnaround time, volume and bottlenecks at a glance</a:t>
+            </a:r>
+          </a:p>
+        </p:txBody>
+      </p:sp>
+      <p:sp>
+        <p:nvSpPr>
+          <p:cNvPr id="6" name="Title 5"/>
+          <p:cNvSpPr>
+            <a:spLocks noGrp="1"/>
+          </p:cNvSpPr>
+          <p:nvPr>
+            <p:ph type="title"/>
           </p:nvPr>
         </p:nvSpPr>
         <p:spPr/>
@@ -12590,19 +12881,25 @@
           <a:lstStyle/>
           <a:p>
             <a:r>
-              <a:t>Before</a:t>
-            </a:r>
-          </a:p>
-        </p:txBody>
-      </p:sp>
-      <p:sp>
-        <p:nvSpPr>
-          <p:cNvPr id="3" name="Content Placeholder 2"/>
-          <p:cNvSpPr>
-            <a:spLocks noGrp="1"/>
-          </p:cNvSpPr>
-          <p:nvPr>
-            <p:ph idx="2" sz="half"/>
+              <a:t>What's next</a:t>
+            </a:r>
+          </a:p>
+        </p:txBody>
+      </p:sp>
+      <p:sp>
+        <p:nvSpPr>
+          <p:cNvPr id="6" name="Footer Placeholder 5">
+            <a:extLst>
+              <a:ext uri="{FF2B5EF4-FFF2-40B4-BE49-F238E27FC236}">
+                <a16:creationId xmlns:a16="http://schemas.microsoft.com/office/drawing/2014/main" id="{50152516-C652-40E0-A0E5-B9ADA7B8AF97}"/>
+              </a:ext>
+            </a:extLst>
+          </p:cNvPr>
+          <p:cNvSpPr>
+            <a:spLocks noGrp="1"/>
+          </p:cNvSpPr>
+          <p:nvPr>
+            <p:ph type="ftr" sz="quarter" idx="17"/>
           </p:nvPr>
         </p:nvSpPr>
         <p:spPr/>
@@ -12610,134 +12907,6 @@
           <a:bodyPr/>
           <a:lstStyle/>
           <a:p>
-            <a:pPr/>
-            <a:r>
-              <a:t>Hours of manual reformatting per document</a:t>
-            </a:r>
-          </a:p>
-          <a:p>
-            <a:pPr/>
-            <a:r>
-              <a:t>Versions scattered across inboxes and drives</a:t>
-            </a:r>
-          </a:p>
-          <a:p>
-            <a:pPr/>
-            <a:r>
-              <a:t>Status invisible; chased by email</a:t>
-            </a:r>
-          </a:p>
-          <a:p>
-            <a:pPr/>
-            <a:r>
-              <a:t>No reliable history or audit trail</a:t>
-            </a:r>
-          </a:p>
-        </p:txBody>
-      </p:sp>
-      <p:sp>
-        <p:nvSpPr>
-          <p:cNvPr id="4" name="Text Placeholder 3"/>
-          <p:cNvSpPr>
-            <a:spLocks noGrp="1"/>
-          </p:cNvSpPr>
-          <p:nvPr>
-            <p:ph type="body" idx="3" sz="quarter"/>
-          </p:nvPr>
-        </p:nvSpPr>
-        <p:spPr/>
-        <p:txBody>
-          <a:bodyPr/>
-          <a:lstStyle/>
-          <a:p>
-            <a:r>
-              <a:t>After</a:t>
-            </a:r>
-          </a:p>
-        </p:txBody>
-      </p:sp>
-      <p:sp>
-        <p:nvSpPr>
-          <p:cNvPr id="5" name="Content Placeholder 4"/>
-          <p:cNvSpPr>
-            <a:spLocks noGrp="1"/>
-          </p:cNvSpPr>
-          <p:nvPr>
-            <p:ph idx="13" sz="half"/>
-          </p:nvPr>
-        </p:nvSpPr>
-        <p:spPr/>
-        <p:txBody>
-          <a:bodyPr/>
-          <a:lstStyle/>
-          <a:p>
-            <a:pPr/>
-            <a:r>
-              <a:t>Branded PDF + Word generated in minutes</a:t>
-            </a:r>
-          </a:p>
-          <a:p>
-            <a:pPr/>
-            <a:r>
-              <a:t>One repository = single source of truth</a:t>
-            </a:r>
-          </a:p>
-          <a:p>
-            <a:pPr/>
-            <a:r>
-              <a:t>Self-service dashboard with live status</a:t>
-            </a:r>
-          </a:p>
-          <a:p>
-            <a:pPr/>
-            <a:r>
-              <a:t>Full version story: who requested and approved</a:t>
-            </a:r>
-          </a:p>
-        </p:txBody>
-      </p:sp>
-      <p:sp>
-        <p:nvSpPr>
-          <p:cNvPr id="6" name="Title 5"/>
-          <p:cNvSpPr>
-            <a:spLocks noGrp="1"/>
-          </p:cNvSpPr>
-          <p:nvPr>
-            <p:ph type="title"/>
-          </p:nvPr>
-        </p:nvSpPr>
-        <p:spPr/>
-        <p:txBody>
-          <a:bodyPr/>
-          <a:lstStyle/>
-          <a:p>
-            <a:r>
-              <a:t>Before vs After</a:t>
-            </a:r>
-          </a:p>
-        </p:txBody>
-      </p:sp>
-      <p:sp>
-        <p:nvSpPr>
-          <p:cNvPr id="18" name="Footer Placeholder 17">
-            <a:extLst>
-              <a:ext uri="{FF2B5EF4-FFF2-40B4-BE49-F238E27FC236}">
-                <a16:creationId xmlns:a16="http://schemas.microsoft.com/office/drawing/2014/main" id="{78C02DC0-1D54-4077-A3AE-CE6AE7382049}"/>
-              </a:ext>
-            </a:extLst>
-          </p:cNvPr>
-          <p:cNvSpPr>
-            <a:spLocks noGrp="1"/>
-          </p:cNvSpPr>
-          <p:nvPr>
-            <p:ph type="ftr" sz="quarter" idx="15"/>
-          </p:nvPr>
-        </p:nvSpPr>
-        <p:spPr/>
-        <p:txBody>
-          <a:bodyPr/>
-          <a:lstStyle/>
-          <a:p>
             <a:r>
               <a:t>Powered by Partnership. Driven by Innovation.</a:t>
             </a:r>
@@ -12746,18 +12915,18 @@
       </p:sp>
       <p:sp>
         <p:nvSpPr>
-          <p:cNvPr id="19" name="Slide Number Placeholder 18">
-            <a:extLst>
-              <a:ext uri="{FF2B5EF4-FFF2-40B4-BE49-F238E27FC236}">
-                <a16:creationId xmlns:a16="http://schemas.microsoft.com/office/drawing/2014/main" id="{C30F974C-5E8C-48FE-9EBF-6D61C4ACCDF7}"/>
-              </a:ext>
-            </a:extLst>
-          </p:cNvPr>
-          <p:cNvSpPr>
-            <a:spLocks noGrp="1"/>
-          </p:cNvSpPr>
-          <p:nvPr>
-            <p:ph type="sldNum" sz="quarter" idx="16"/>
+          <p:cNvPr id="7" name="Slide Number Placeholder 6">
+            <a:extLst>
+              <a:ext uri="{FF2B5EF4-FFF2-40B4-BE49-F238E27FC236}">
+                <a16:creationId xmlns:a16="http://schemas.microsoft.com/office/drawing/2014/main" id="{42E6685B-740F-4E4A-90C9-64331236C977}"/>
+              </a:ext>
+            </a:extLst>
+          </p:cNvPr>
+          <p:cNvSpPr>
+            <a:spLocks noGrp="1"/>
+          </p:cNvSpPr>
+          <p:nvPr>
+            <p:ph type="sldNum" sz="quarter" idx="18"/>
           </p:nvPr>
         </p:nvSpPr>
         <p:spPr/>
@@ -12808,7 +12977,7 @@
           <a:lstStyle/>
           <a:p>
             <a:r>
-              <a:t>Cutting waste out of the policy value stream</a:t>
+              <a:t>Automation does the heavy lifting — people stay in control.</a:t>
             </a:r>
           </a:p>
         </p:txBody>
@@ -12829,7 +12998,7 @@
           <a:lstStyle/>
           <a:p>
             <a:r>
-              <a:t>LEAN Benefits</a:t>
+              <a:t>One process. One source of truth.</a:t>
             </a:r>
           </a:p>
         </p:txBody>
@@ -12875,302 +13044,6 @@
             <a:extLst>
               <a:ext uri="{FF2B5EF4-FFF2-40B4-BE49-F238E27FC236}">
                 <a16:creationId xmlns:a16="http://schemas.microsoft.com/office/drawing/2014/main" id="{39CFBA96-2B00-4625-85D6-B57F3F14263B}"/>
-              </a:ext>
-            </a:extLst>
-          </p:cNvPr>
-          <p:cNvSpPr>
-            <a:spLocks noGrp="1"/>
-          </p:cNvSpPr>
-          <p:nvPr>
-            <p:ph type="sldNum" sz="quarter" idx="12"/>
-          </p:nvPr>
-        </p:nvSpPr>
-        <p:spPr/>
-        <p:txBody>
-          <a:bodyPr/>
-          <a:lstStyle/>
-          <a:p>
-            <a:fld id="{66F6B9C1-1745-48B0-A8CA-B72E47831159}" type="slidenum">
-              <a:rPr lang="en-GB" noProof="0" smtClean="0"/>
-              <a:pPr/>
-              <a:t>‹#›</a:t>
-            </a:fld>
-            <a:endParaRPr lang="en-GB" noProof="0"/>
-          </a:p>
-        </p:txBody>
-      </p:sp>
-    </p:spTree>
-  </p:cSld>
-  <p:clrMapOvr>
-    <a:masterClrMapping/>
-  </p:clrMapOvr>
-</p:sld>
-</file>
-
-<file path=ppt/slides/slide8.xml><?xml version="1.0" encoding="utf-8"?>
-<p:sld xmlns:a="http://schemas.openxmlformats.org/drawingml/2006/main" xmlns:p="http://schemas.openxmlformats.org/presentationml/2006/main" xmlns:r="http://schemas.openxmlformats.org/officeDocument/2006/relationships">
-  <p:cSld>
-    <p:spTree>
-      <p:nvGrpSpPr>
-        <p:cNvPr id="1" name=""/>
-        <p:cNvGrpSpPr/>
-        <p:nvPr/>
-      </p:nvGrpSpPr>
-      <p:grpSpPr/>
-      <p:sp>
-        <p:nvSpPr>
-          <p:cNvPr id="2" name="Content Placeholder 1"/>
-          <p:cNvSpPr>
-            <a:spLocks noGrp="1"/>
-          </p:cNvSpPr>
-          <p:nvPr>
-            <p:ph idx="1"/>
-          </p:nvPr>
-        </p:nvSpPr>
-        <p:spPr/>
-        <p:txBody>
-          <a:bodyPr/>
-          <a:lstStyle/>
-          <a:p>
-            <a:pPr/>
-            <a:r>
-              <a:t>Waiting — automatic notifications replace email chasing</a:t>
-            </a:r>
-          </a:p>
-          <a:p>
-            <a:pPr/>
-            <a:r>
-              <a:t>Over-processing — no manual reformatting; the template is applied once, consistently</a:t>
-            </a:r>
-          </a:p>
-          <a:p>
-            <a:pPr/>
-            <a:r>
-              <a:t>Defects — single source of truth + verified renders + preserved versions</a:t>
-            </a:r>
-          </a:p>
-          <a:p>
-            <a:pPr/>
-            <a:r>
-              <a:t>Inventory — no 5+ parallel drafts; one current version and a clean history</a:t>
-            </a:r>
-          </a:p>
-          <a:p>
-            <a:pPr/>
-            <a:r>
-              <a:t>Motion / Transport — everything in one place (repo + dashboard); no file hunting</a:t>
-            </a:r>
-          </a:p>
-          <a:p>
-            <a:pPr/>
-            <a:r>
-              <a:t>Non-used talent — design &amp; legal focus on content, not layout</a:t>
-            </a:r>
-          </a:p>
-        </p:txBody>
-      </p:sp>
-      <p:sp>
-        <p:nvSpPr>
-          <p:cNvPr id="3" name="Title 2"/>
-          <p:cNvSpPr>
-            <a:spLocks noGrp="1"/>
-          </p:cNvSpPr>
-          <p:nvPr>
-            <p:ph type="title"/>
-          </p:nvPr>
-        </p:nvSpPr>
-        <p:spPr/>
-        <p:txBody>
-          <a:bodyPr/>
-          <a:lstStyle/>
-          <a:p>
-            <a:r>
-              <a:t>Waste eliminated</a:t>
-            </a:r>
-          </a:p>
-        </p:txBody>
-      </p:sp>
-      <p:sp>
-        <p:nvSpPr>
-          <p:cNvPr id="4" name="Footer Placeholder 3">
-            <a:extLst>
-              <a:ext uri="{FF2B5EF4-FFF2-40B4-BE49-F238E27FC236}">
-                <a16:creationId xmlns:a16="http://schemas.microsoft.com/office/drawing/2014/main" id="{37D5DA99-A6A5-4B1D-838D-A53201A41331}"/>
-              </a:ext>
-            </a:extLst>
-          </p:cNvPr>
-          <p:cNvSpPr>
-            <a:spLocks noGrp="1"/>
-          </p:cNvSpPr>
-          <p:nvPr>
-            <p:ph type="ftr" sz="quarter" idx="11"/>
-          </p:nvPr>
-        </p:nvSpPr>
-        <p:spPr/>
-        <p:txBody>
-          <a:bodyPr/>
-          <a:lstStyle/>
-          <a:p>
-            <a:r>
-              <a:t>Powered by Partnership. Driven by Innovation.</a:t>
-            </a:r>
-          </a:p>
-        </p:txBody>
-      </p:sp>
-      <p:sp>
-        <p:nvSpPr>
-          <p:cNvPr id="5" name="Slide Number Placeholder 4">
-            <a:extLst>
-              <a:ext uri="{FF2B5EF4-FFF2-40B4-BE49-F238E27FC236}">
-                <a16:creationId xmlns:a16="http://schemas.microsoft.com/office/drawing/2014/main" id="{CD3E2ED3-B7CA-4509-819E-F58E7A0DAC4F}"/>
-              </a:ext>
-            </a:extLst>
-          </p:cNvPr>
-          <p:cNvSpPr>
-            <a:spLocks noGrp="1"/>
-          </p:cNvSpPr>
-          <p:nvPr>
-            <p:ph type="sldNum" sz="quarter" idx="12"/>
-          </p:nvPr>
-        </p:nvSpPr>
-        <p:spPr/>
-        <p:txBody>
-          <a:bodyPr/>
-          <a:lstStyle/>
-          <a:p>
-            <a:fld id="{66F6B9C1-1745-48B0-A8CA-B72E47831159}" type="slidenum">
-              <a:rPr lang="en-GB" noProof="0" smtClean="0"/>
-              <a:pPr/>
-              <a:t>‹#›</a:t>
-            </a:fld>
-            <a:endParaRPr lang="en-GB" noProof="0"/>
-          </a:p>
-        </p:txBody>
-      </p:sp>
-    </p:spTree>
-  </p:cSld>
-  <p:clrMapOvr>
-    <a:masterClrMapping/>
-  </p:clrMapOvr>
-</p:sld>
-</file>
-
-<file path=ppt/slides/slide9.xml><?xml version="1.0" encoding="utf-8"?>
-<p:sld xmlns:a="http://schemas.openxmlformats.org/drawingml/2006/main" xmlns:p="http://schemas.openxmlformats.org/presentationml/2006/main" xmlns:r="http://schemas.openxmlformats.org/officeDocument/2006/relationships">
-  <p:cSld>
-    <p:spTree>
-      <p:nvGrpSpPr>
-        <p:cNvPr id="1" name=""/>
-        <p:cNvGrpSpPr/>
-        <p:nvPr/>
-      </p:nvGrpSpPr>
-      <p:grpSpPr/>
-      <p:sp>
-        <p:nvSpPr>
-          <p:cNvPr id="2" name="Content Placeholder 1"/>
-          <p:cNvSpPr>
-            <a:spLocks noGrp="1"/>
-          </p:cNvSpPr>
-          <p:nvPr>
-            <p:ph idx="1"/>
-          </p:nvPr>
-        </p:nvSpPr>
-        <p:spPr/>
-        <p:txBody>
-          <a:bodyPr/>
-          <a:lstStyle/>
-          <a:p>
-            <a:pPr/>
-            <a:r>
-              <a:t>Value — every step maps to what the requester actually needs</a:t>
-            </a:r>
-          </a:p>
-          <a:p>
-            <a:pPr/>
-            <a:r>
-              <a:t>Value stream — request → format → review → approve → publish, fully visible</a:t>
-            </a:r>
-          </a:p>
-          <a:p>
-            <a:pPr/>
-            <a:r>
-              <a:t>Flow — no hand-offs stuck in inboxes; work moves continuously</a:t>
-            </a:r>
-          </a:p>
-          <a:p>
-            <a:pPr/>
-            <a:r>
-              <a:t>Pull — changes made on demand; requesters notified when ready</a:t>
-            </a:r>
-          </a:p>
-          <a:p>
-            <a:pPr/>
-            <a:r>
-              <a:t>Standardised work — one template, one registry, a written playbook any agent can follow</a:t>
-            </a:r>
-          </a:p>
-          <a:p>
-            <a:pPr/>
-            <a:r>
-              <a:t>Visual management — dashboard status chips, review queue and version history</a:t>
-            </a:r>
-          </a:p>
-        </p:txBody>
-      </p:sp>
-      <p:sp>
-        <p:nvSpPr>
-          <p:cNvPr id="3" name="Title 2"/>
-          <p:cNvSpPr>
-            <a:spLocks noGrp="1"/>
-          </p:cNvSpPr>
-          <p:nvPr>
-            <p:ph type="title"/>
-          </p:nvPr>
-        </p:nvSpPr>
-        <p:spPr/>
-        <p:txBody>
-          <a:bodyPr/>
-          <a:lstStyle/>
-          <a:p>
-            <a:r>
-              <a:t>LEAN principles in action</a:t>
-            </a:r>
-          </a:p>
-        </p:txBody>
-      </p:sp>
-      <p:sp>
-        <p:nvSpPr>
-          <p:cNvPr id="4" name="Footer Placeholder 3">
-            <a:extLst>
-              <a:ext uri="{FF2B5EF4-FFF2-40B4-BE49-F238E27FC236}">
-                <a16:creationId xmlns:a16="http://schemas.microsoft.com/office/drawing/2014/main" id="{37D5DA99-A6A5-4B1D-838D-A53201A41331}"/>
-              </a:ext>
-            </a:extLst>
-          </p:cNvPr>
-          <p:cNvSpPr>
-            <a:spLocks noGrp="1"/>
-          </p:cNvSpPr>
-          <p:nvPr>
-            <p:ph type="ftr" sz="quarter" idx="11"/>
-          </p:nvPr>
-        </p:nvSpPr>
-        <p:spPr/>
-        <p:txBody>
-          <a:bodyPr/>
-          <a:lstStyle/>
-          <a:p>
-            <a:r>
-              <a:t>Powered by Partnership. Driven by Innovation.</a:t>
-            </a:r>
-          </a:p>
-        </p:txBody>
-      </p:sp>
-      <p:sp>
-        <p:nvSpPr>
-          <p:cNvPr id="5" name="Slide Number Placeholder 4">
-            <a:extLst>
-              <a:ext uri="{FF2B5EF4-FFF2-40B4-BE49-F238E27FC236}">
-                <a16:creationId xmlns:a16="http://schemas.microsoft.com/office/drawing/2014/main" id="{CD3E2ED3-B7CA-4509-819E-F58E7A0DAC4F}"/>
               </a:ext>
             </a:extLst>
           </p:cNvPr>

</xml_diff>

<commit_message>
Presentation: custom BioMar-blue filled icons (rounded) replacing emoji
Add a consistent set of 18 filled, rounded BioMar-blue icons (rendered from SVG)
and place them in every tile instead of emoji — clean and on-brand.

Co-Authored-By: Claude Opus 4.8 <noreply@anthropic.com>
Claude-Session: https://claude.ai/code/session_01W3gw8scX9B7oMC33JPxjbS
</commit_message>
<xml_diff>
--- a/BioMar_Policy_Library_2026.pptx
+++ b/BioMar_Policy_Library_2026.pptx
@@ -11651,15 +11651,12 @@
         </p:nvSpPr>
         <p:spPr/>
         <p:txBody>
-          <a:bodyPr wrap="square"/>
+          <a:bodyPr wrap="square" tIns="822960"/>
           <a:lstStyle/>
           <a:p>
-            <a:r>
-              <a:rPr sz="2400"/>
-              <a:t>🧩  </a:t>
-            </a:r>
-            <a:r>
-              <a:rPr sz="1700" b="1">
+            <a:pPr algn="ctr"/>
+            <a:r>
+              <a:rPr sz="1600" b="1">
                 <a:solidFill>
                   <a:srgbClr val="1C4076"/>
                 </a:solidFill>
@@ -11668,8 +11665,9 @@
             </a:r>
           </a:p>
           <a:p>
-            <a:r>
-              <a:rPr sz="1300">
+            <a:pPr algn="ctr"/>
+            <a:r>
+              <a:rPr sz="1250">
                 <a:solidFill>
                   <a:srgbClr val="6B87A4"/>
                 </a:solidFill>
@@ -11691,15 +11689,12 @@
         </p:nvSpPr>
         <p:spPr/>
         <p:txBody>
-          <a:bodyPr wrap="square"/>
+          <a:bodyPr wrap="square" tIns="822960"/>
           <a:lstStyle/>
           <a:p>
-            <a:r>
-              <a:rPr sz="2400"/>
-              <a:t>🗂️  </a:t>
-            </a:r>
-            <a:r>
-              <a:rPr sz="1700" b="1">
+            <a:pPr algn="ctr"/>
+            <a:r>
+              <a:rPr sz="1600" b="1">
                 <a:solidFill>
                   <a:srgbClr val="1C4076"/>
                 </a:solidFill>
@@ -11708,8 +11703,9 @@
             </a:r>
           </a:p>
           <a:p>
-            <a:r>
-              <a:rPr sz="1300">
+            <a:pPr algn="ctr"/>
+            <a:r>
+              <a:rPr sz="1250">
                 <a:solidFill>
                   <a:srgbClr val="6B87A4"/>
                 </a:solidFill>
@@ -11731,15 +11727,12 @@
         </p:nvSpPr>
         <p:spPr/>
         <p:txBody>
-          <a:bodyPr wrap="square"/>
+          <a:bodyPr wrap="square" tIns="822960"/>
           <a:lstStyle/>
           <a:p>
-            <a:r>
-              <a:rPr sz="2400"/>
-              <a:t>✉️  </a:t>
-            </a:r>
-            <a:r>
-              <a:rPr sz="1700" b="1">
+            <a:pPr algn="ctr"/>
+            <a:r>
+              <a:rPr sz="1600" b="1">
                 <a:solidFill>
                   <a:srgbClr val="1C4076"/>
                 </a:solidFill>
@@ -11748,8 +11741,9 @@
             </a:r>
           </a:p>
           <a:p>
-            <a:r>
-              <a:rPr sz="1300">
+            <a:pPr algn="ctr"/>
+            <a:r>
+              <a:rPr sz="1250">
                 <a:solidFill>
                   <a:srgbClr val="6B87A4"/>
                 </a:solidFill>
@@ -11771,15 +11765,12 @@
         </p:nvSpPr>
         <p:spPr/>
         <p:txBody>
-          <a:bodyPr wrap="square"/>
+          <a:bodyPr wrap="square" tIns="822960"/>
           <a:lstStyle/>
           <a:p>
-            <a:r>
-              <a:rPr sz="2400"/>
-              <a:t>❓  </a:t>
-            </a:r>
-            <a:r>
-              <a:rPr sz="1700" b="1">
+            <a:pPr algn="ctr"/>
+            <a:r>
+              <a:rPr sz="1600" b="1">
                 <a:solidFill>
                   <a:srgbClr val="1C4076"/>
                 </a:solidFill>
@@ -11788,8 +11779,9 @@
             </a:r>
           </a:p>
           <a:p>
-            <a:r>
-              <a:rPr sz="1300">
+            <a:pPr algn="ctr"/>
+            <a:r>
+              <a:rPr sz="1250">
                 <a:solidFill>
                   <a:srgbClr val="6B87A4"/>
                 </a:solidFill>
@@ -11811,15 +11803,12 @@
         </p:nvSpPr>
         <p:spPr/>
         <p:txBody>
-          <a:bodyPr wrap="square"/>
+          <a:bodyPr wrap="square" tIns="822960"/>
           <a:lstStyle/>
           <a:p>
-            <a:r>
-              <a:rPr sz="2400"/>
-              <a:t>🕒  </a:t>
-            </a:r>
-            <a:r>
-              <a:rPr sz="1700" b="1">
+            <a:pPr algn="ctr"/>
+            <a:r>
+              <a:rPr sz="1600" b="1">
                 <a:solidFill>
                   <a:srgbClr val="1C4076"/>
                 </a:solidFill>
@@ -11828,8 +11817,9 @@
             </a:r>
           </a:p>
           <a:p>
-            <a:r>
-              <a:rPr sz="1300">
+            <a:pPr algn="ctr"/>
+            <a:r>
+              <a:rPr sz="1250">
                 <a:solidFill>
                   <a:srgbClr val="6B87A4"/>
                 </a:solidFill>
@@ -11851,15 +11841,12 @@
         </p:nvSpPr>
         <p:spPr/>
         <p:txBody>
-          <a:bodyPr wrap="square"/>
+          <a:bodyPr wrap="square" tIns="822960"/>
           <a:lstStyle/>
           <a:p>
-            <a:r>
-              <a:rPr sz="2400"/>
-              <a:t>⚠️  </a:t>
-            </a:r>
-            <a:r>
-              <a:rPr sz="1700" b="1">
+            <a:pPr algn="ctr"/>
+            <a:r>
+              <a:rPr sz="1600" b="1">
                 <a:solidFill>
                   <a:srgbClr val="1C4076"/>
                 </a:solidFill>
@@ -11868,8 +11855,9 @@
             </a:r>
           </a:p>
           <a:p>
-            <a:r>
-              <a:rPr sz="1300">
+            <a:pPr algn="ctr"/>
+            <a:r>
+              <a:rPr sz="1250">
                 <a:solidFill>
                   <a:srgbClr val="6B87A4"/>
                 </a:solidFill>
@@ -11957,6 +11945,150 @@
           </a:p>
         </p:txBody>
       </p:sp>
+      <p:pic>
+        <p:nvPicPr>
+          <p:cNvPr id="9" name="Picture 8" descr="scatter.png"/>
+          <p:cNvPicPr>
+            <a:picLocks noChangeAspect="1"/>
+          </p:cNvPicPr>
+          <p:nvPr/>
+        </p:nvPicPr>
+        <p:blipFill>
+          <a:blip r:embed="rId2"/>
+          <a:stretch>
+            <a:fillRect/>
+          </a:stretch>
+        </p:blipFill>
+        <p:spPr>
+          <a:xfrm>
+            <a:off x="1998155" y="1501839"/>
+            <a:ext cx="585216" cy="585216"/>
+          </a:xfrm>
+          <a:prstGeom prst="rect">
+            <a:avLst/>
+          </a:prstGeom>
+        </p:spPr>
+      </p:pic>
+      <p:pic>
+        <p:nvPicPr>
+          <p:cNvPr id="10" name="Picture 9" descr="layers.png"/>
+          <p:cNvPicPr>
+            <a:picLocks noChangeAspect="1"/>
+          </p:cNvPicPr>
+          <p:nvPr/>
+        </p:nvPicPr>
+        <p:blipFill>
+          <a:blip r:embed="rId3"/>
+          <a:stretch>
+            <a:fillRect/>
+          </a:stretch>
+        </p:blipFill>
+        <p:spPr>
+          <a:xfrm>
+            <a:off x="5802661" y="1506463"/>
+            <a:ext cx="585216" cy="585216"/>
+          </a:xfrm>
+          <a:prstGeom prst="rect">
+            <a:avLst/>
+          </a:prstGeom>
+        </p:spPr>
+      </p:pic>
+      <p:pic>
+        <p:nvPicPr>
+          <p:cNvPr id="11" name="Picture 10" descr="mail.png"/>
+          <p:cNvPicPr>
+            <a:picLocks noChangeAspect="1"/>
+          </p:cNvPicPr>
+          <p:nvPr/>
+        </p:nvPicPr>
+        <p:blipFill>
+          <a:blip r:embed="rId4"/>
+          <a:stretch>
+            <a:fillRect/>
+          </a:stretch>
+        </p:blipFill>
+        <p:spPr>
+          <a:xfrm>
+            <a:off x="9607167" y="1501838"/>
+            <a:ext cx="585216" cy="585216"/>
+          </a:xfrm>
+          <a:prstGeom prst="rect">
+            <a:avLst/>
+          </a:prstGeom>
+        </p:spPr>
+      </p:pic>
+      <p:pic>
+        <p:nvPicPr>
+          <p:cNvPr id="12" name="Picture 11" descr="question.png"/>
+          <p:cNvPicPr>
+            <a:picLocks noChangeAspect="1"/>
+          </p:cNvPicPr>
+          <p:nvPr/>
+        </p:nvPicPr>
+        <p:blipFill>
+          <a:blip r:embed="rId5"/>
+          <a:stretch>
+            <a:fillRect/>
+          </a:stretch>
+        </p:blipFill>
+        <p:spPr>
+          <a:xfrm>
+            <a:off x="1998155" y="3999929"/>
+            <a:ext cx="585216" cy="585216"/>
+          </a:xfrm>
+          <a:prstGeom prst="rect">
+            <a:avLst/>
+          </a:prstGeom>
+        </p:spPr>
+      </p:pic>
+      <p:pic>
+        <p:nvPicPr>
+          <p:cNvPr id="13" name="Picture 12" descr="clock.png"/>
+          <p:cNvPicPr>
+            <a:picLocks noChangeAspect="1"/>
+          </p:cNvPicPr>
+          <p:nvPr/>
+        </p:nvPicPr>
+        <p:blipFill>
+          <a:blip r:embed="rId6"/>
+          <a:stretch>
+            <a:fillRect/>
+          </a:stretch>
+        </p:blipFill>
+        <p:spPr>
+          <a:xfrm>
+            <a:off x="5808698" y="4004553"/>
+            <a:ext cx="585216" cy="585216"/>
+          </a:xfrm>
+          <a:prstGeom prst="rect">
+            <a:avLst/>
+          </a:prstGeom>
+        </p:spPr>
+      </p:pic>
+      <p:pic>
+        <p:nvPicPr>
+          <p:cNvPr id="14" name="Picture 13" descr="alert.png"/>
+          <p:cNvPicPr>
+            <a:picLocks noChangeAspect="1"/>
+          </p:cNvPicPr>
+          <p:nvPr/>
+        </p:nvPicPr>
+        <p:blipFill>
+          <a:blip r:embed="rId7"/>
+          <a:stretch>
+            <a:fillRect/>
+          </a:stretch>
+        </p:blipFill>
+        <p:spPr>
+          <a:xfrm>
+            <a:off x="9619242" y="3997833"/>
+            <a:ext cx="585216" cy="585216"/>
+          </a:xfrm>
+          <a:prstGeom prst="rect">
+            <a:avLst/>
+          </a:prstGeom>
+        </p:spPr>
+      </p:pic>
     </p:spTree>
   </p:cSld>
   <p:clrMapOvr>
@@ -11987,15 +12119,12 @@
         </p:nvSpPr>
         <p:spPr/>
         <p:txBody>
-          <a:bodyPr wrap="square"/>
+          <a:bodyPr wrap="square" tIns="822960"/>
           <a:lstStyle/>
           <a:p>
-            <a:r>
-              <a:rPr sz="2400"/>
-              <a:t>📥  </a:t>
-            </a:r>
-            <a:r>
-              <a:rPr sz="1700" b="1">
+            <a:pPr algn="ctr"/>
+            <a:r>
+              <a:rPr sz="1600" b="1">
                 <a:solidFill>
                   <a:srgbClr val="1C4076"/>
                 </a:solidFill>
@@ -12004,8 +12133,9 @@
             </a:r>
           </a:p>
           <a:p>
-            <a:r>
-              <a:rPr sz="1300">
+            <a:pPr algn="ctr"/>
+            <a:r>
+              <a:rPr sz="1250">
                 <a:solidFill>
                   <a:srgbClr val="6B87A4"/>
                 </a:solidFill>
@@ -12027,15 +12157,12 @@
         </p:nvSpPr>
         <p:spPr/>
         <p:txBody>
-          <a:bodyPr wrap="square"/>
+          <a:bodyPr wrap="square" tIns="822960"/>
           <a:lstStyle/>
           <a:p>
-            <a:r>
-              <a:rPr sz="2400"/>
-              <a:t>✍️  </a:t>
-            </a:r>
-            <a:r>
-              <a:rPr sz="1700" b="1">
+            <a:pPr algn="ctr"/>
+            <a:r>
+              <a:rPr sz="1600" b="1">
                 <a:solidFill>
                   <a:srgbClr val="1C4076"/>
                 </a:solidFill>
@@ -12044,8 +12171,9 @@
             </a:r>
           </a:p>
           <a:p>
-            <a:r>
-              <a:rPr sz="1300">
+            <a:pPr algn="ctr"/>
+            <a:r>
+              <a:rPr sz="1250">
                 <a:solidFill>
                   <a:srgbClr val="6B87A4"/>
                 </a:solidFill>
@@ -12067,15 +12195,12 @@
         </p:nvSpPr>
         <p:spPr/>
         <p:txBody>
-          <a:bodyPr wrap="square"/>
+          <a:bodyPr wrap="square" tIns="822960"/>
           <a:lstStyle/>
           <a:p>
-            <a:r>
-              <a:rPr sz="2400"/>
-              <a:t>🎨  </a:t>
-            </a:r>
-            <a:r>
-              <a:rPr sz="1700" b="1">
+            <a:pPr algn="ctr"/>
+            <a:r>
+              <a:rPr sz="1600" b="1">
                 <a:solidFill>
                   <a:srgbClr val="1C4076"/>
                 </a:solidFill>
@@ -12084,13 +12209,14 @@
             </a:r>
           </a:p>
           <a:p>
-            <a:r>
-              <a:rPr sz="1300">
+            <a:pPr algn="ctr"/>
+            <a:r>
+              <a:rPr sz="1250">
                 <a:solidFill>
                   <a:srgbClr val="6B87A4"/>
                 </a:solidFill>
               </a:rPr>
-              <a:t>The BioMar template is applied for you, instantly → PDF + editable Word</a:t>
+              <a:t>The BioMar template is applied for you, instantly → PDF + Word</a:t>
             </a:r>
           </a:p>
         </p:txBody>
@@ -12107,15 +12233,12 @@
         </p:nvSpPr>
         <p:spPr/>
         <p:txBody>
-          <a:bodyPr wrap="square"/>
+          <a:bodyPr wrap="square" tIns="822960"/>
           <a:lstStyle/>
           <a:p>
-            <a:r>
-              <a:rPr sz="2400"/>
-              <a:t>✅  </a:t>
-            </a:r>
-            <a:r>
-              <a:rPr sz="1700" b="1">
+            <a:pPr algn="ctr"/>
+            <a:r>
+              <a:rPr sz="1600" b="1">
                 <a:solidFill>
                   <a:srgbClr val="1C4076"/>
                 </a:solidFill>
@@ -12124,8 +12247,9 @@
             </a:r>
           </a:p>
           <a:p>
-            <a:r>
-              <a:rPr sz="1300">
+            <a:pPr algn="ctr"/>
+            <a:r>
+              <a:rPr sz="1250">
                 <a:solidFill>
                   <a:srgbClr val="6B87A4"/>
                 </a:solidFill>
@@ -12213,6 +12337,102 @@
           </a:p>
         </p:txBody>
       </p:sp>
+      <p:pic>
+        <p:nvPicPr>
+          <p:cNvPr id="8" name="Picture 7" descr="inbox.png"/>
+          <p:cNvPicPr>
+            <a:picLocks noChangeAspect="1"/>
+          </p:cNvPicPr>
+          <p:nvPr/>
+        </p:nvPicPr>
+        <p:blipFill>
+          <a:blip r:embed="rId2"/>
+          <a:stretch>
+            <a:fillRect/>
+          </a:stretch>
+        </p:blipFill>
+        <p:spPr>
+          <a:xfrm>
+            <a:off x="2898120" y="1467432"/>
+            <a:ext cx="585216" cy="585216"/>
+          </a:xfrm>
+          <a:prstGeom prst="rect">
+            <a:avLst/>
+          </a:prstGeom>
+        </p:spPr>
+      </p:pic>
+      <p:pic>
+        <p:nvPicPr>
+          <p:cNvPr id="9" name="Picture 8" descr="document.png"/>
+          <p:cNvPicPr>
+            <a:picLocks noChangeAspect="1"/>
+          </p:cNvPicPr>
+          <p:nvPr/>
+        </p:nvPicPr>
+        <p:blipFill>
+          <a:blip r:embed="rId3"/>
+          <a:stretch>
+            <a:fillRect/>
+          </a:stretch>
+        </p:blipFill>
+        <p:spPr>
+          <a:xfrm>
+            <a:off x="8687290" y="1467432"/>
+            <a:ext cx="585216" cy="585216"/>
+          </a:xfrm>
+          <a:prstGeom prst="rect">
+            <a:avLst/>
+          </a:prstGeom>
+        </p:spPr>
+      </p:pic>
+      <p:pic>
+        <p:nvPicPr>
+          <p:cNvPr id="10" name="Picture 9" descr="pen.png"/>
+          <p:cNvPicPr>
+            <a:picLocks noChangeAspect="1"/>
+          </p:cNvPicPr>
+          <p:nvPr/>
+        </p:nvPicPr>
+        <p:blipFill>
+          <a:blip r:embed="rId4"/>
+          <a:stretch>
+            <a:fillRect/>
+          </a:stretch>
+        </p:blipFill>
+        <p:spPr>
+          <a:xfrm>
+            <a:off x="2908753" y="3987432"/>
+            <a:ext cx="585216" cy="585216"/>
+          </a:xfrm>
+          <a:prstGeom prst="rect">
+            <a:avLst/>
+          </a:prstGeom>
+        </p:spPr>
+      </p:pic>
+      <p:pic>
+        <p:nvPicPr>
+          <p:cNvPr id="11" name="Picture 10" descr="check.png"/>
+          <p:cNvPicPr>
+            <a:picLocks noChangeAspect="1"/>
+          </p:cNvPicPr>
+          <p:nvPr/>
+        </p:nvPicPr>
+        <p:blipFill>
+          <a:blip r:embed="rId5"/>
+          <a:stretch>
+            <a:fillRect/>
+          </a:stretch>
+        </p:blipFill>
+        <p:spPr>
+          <a:xfrm>
+            <a:off x="8679451" y="3987432"/>
+            <a:ext cx="585216" cy="585216"/>
+          </a:xfrm>
+          <a:prstGeom prst="rect">
+            <a:avLst/>
+          </a:prstGeom>
+        </p:spPr>
+      </p:pic>
     </p:spTree>
   </p:cSld>
   <p:clrMapOvr>
@@ -12243,23 +12463,80 @@
         </p:nvSpPr>
         <p:spPr/>
         <p:txBody>
+          <a:bodyPr lIns="502920"/>
+          <a:lstStyle/>
+          <a:p>
+            <a:r>
+              <a:t>Before</a:t>
+            </a:r>
+          </a:p>
+        </p:txBody>
+      </p:sp>
+      <p:sp>
+        <p:nvSpPr>
+          <p:cNvPr id="3" name="Content Placeholder 2"/>
+          <p:cNvSpPr>
+            <a:spLocks noGrp="1"/>
+          </p:cNvSpPr>
+          <p:nvPr>
+            <p:ph idx="2" sz="half"/>
+          </p:nvPr>
+        </p:nvSpPr>
+        <p:spPr/>
+        <p:txBody>
           <a:bodyPr/>
           <a:lstStyle/>
           <a:p>
             <a:r>
-              <a:t>🐌  Before</a:t>
-            </a:r>
-          </a:p>
-        </p:txBody>
-      </p:sp>
-      <p:sp>
-        <p:nvSpPr>
-          <p:cNvPr id="3" name="Content Placeholder 2"/>
-          <p:cNvSpPr>
-            <a:spLocks noGrp="1"/>
-          </p:cNvSpPr>
-          <p:nvPr>
-            <p:ph idx="2" sz="half"/>
+              <a:t>Hours of manual reformatting</a:t>
+            </a:r>
+          </a:p>
+          <a:p>
+            <a:r>
+              <a:t>Versions scattered everywhere</a:t>
+            </a:r>
+          </a:p>
+          <a:p>
+            <a:r>
+              <a:t>Status invisible, chased by email</a:t>
+            </a:r>
+          </a:p>
+          <a:p>
+            <a:r>
+              <a:t>No reliable history</a:t>
+            </a:r>
+          </a:p>
+        </p:txBody>
+      </p:sp>
+      <p:sp>
+        <p:nvSpPr>
+          <p:cNvPr id="4" name="Text Placeholder 3"/>
+          <p:cNvSpPr>
+            <a:spLocks noGrp="1"/>
+          </p:cNvSpPr>
+          <p:nvPr>
+            <p:ph type="body" idx="3" sz="quarter"/>
+          </p:nvPr>
+        </p:nvSpPr>
+        <p:spPr/>
+        <p:txBody>
+          <a:bodyPr lIns="502920"/>
+          <a:lstStyle/>
+          <a:p>
+            <a:r>
+              <a:t>After</a:t>
+            </a:r>
+          </a:p>
+        </p:txBody>
+      </p:sp>
+      <p:sp>
+        <p:nvSpPr>
+          <p:cNvPr id="5" name="Content Placeholder 4"/>
+          <p:cNvSpPr>
+            <a:spLocks noGrp="1"/>
+          </p:cNvSpPr>
+          <p:nvPr>
+            <p:ph idx="13" sz="half"/>
           </p:nvPr>
         </p:nvSpPr>
         <p:spPr/>
@@ -12267,86 +12544,21 @@
           <a:bodyPr/>
           <a:lstStyle/>
           <a:p>
-            <a:pPr/>
-            <a:r>
-              <a:t>Hours of manual reformatting</a:t>
-            </a:r>
-          </a:p>
-          <a:p>
-            <a:pPr/>
-            <a:r>
-              <a:t>Versions scattered everywhere</a:t>
-            </a:r>
-          </a:p>
-          <a:p>
-            <a:pPr/>
-            <a:r>
-              <a:t>Status invisible, chased by email</a:t>
-            </a:r>
-          </a:p>
-          <a:p>
-            <a:pPr/>
-            <a:r>
-              <a:t>No reliable history</a:t>
-            </a:r>
-          </a:p>
-        </p:txBody>
-      </p:sp>
-      <p:sp>
-        <p:nvSpPr>
-          <p:cNvPr id="4" name="Text Placeholder 3"/>
-          <p:cNvSpPr>
-            <a:spLocks noGrp="1"/>
-          </p:cNvSpPr>
-          <p:nvPr>
-            <p:ph type="body" idx="3" sz="quarter"/>
-          </p:nvPr>
-        </p:nvSpPr>
-        <p:spPr/>
-        <p:txBody>
-          <a:bodyPr/>
-          <a:lstStyle/>
-          <a:p>
-            <a:r>
-              <a:t>⚡  After</a:t>
-            </a:r>
-          </a:p>
-        </p:txBody>
-      </p:sp>
-      <p:sp>
-        <p:nvSpPr>
-          <p:cNvPr id="5" name="Content Placeholder 4"/>
-          <p:cNvSpPr>
-            <a:spLocks noGrp="1"/>
-          </p:cNvSpPr>
-          <p:nvPr>
-            <p:ph idx="13" sz="half"/>
-          </p:nvPr>
-        </p:nvSpPr>
-        <p:spPr/>
-        <p:txBody>
-          <a:bodyPr/>
-          <a:lstStyle/>
-          <a:p>
-            <a:pPr/>
             <a:r>
               <a:t>Branded PDF + Word in minutes</a:t>
             </a:r>
           </a:p>
           <a:p>
-            <a:pPr/>
             <a:r>
               <a:t>One place, one source of truth</a:t>
             </a:r>
           </a:p>
           <a:p>
-            <a:pPr/>
             <a:r>
               <a:t>Live status on a dashboard</a:t>
             </a:r>
           </a:p>
           <a:p>
-            <a:pPr/>
             <a:r>
               <a:t>Full history: who asked &amp; approved</a:t>
             </a:r>
@@ -12431,6 +12643,54 @@
           </a:p>
         </p:txBody>
       </p:sp>
+      <p:pic>
+        <p:nvPicPr>
+          <p:cNvPr id="20" name="Picture 19" descr="clock.png"/>
+          <p:cNvPicPr>
+            <a:picLocks noChangeAspect="1"/>
+          </p:cNvPicPr>
+          <p:nvPr/>
+        </p:nvPicPr>
+        <p:blipFill>
+          <a:blip r:embed="rId2"/>
+          <a:stretch>
+            <a:fillRect/>
+          </a:stretch>
+        </p:blipFill>
+        <p:spPr>
+          <a:xfrm>
+            <a:off x="495709" y="1458656"/>
+            <a:ext cx="384048" cy="384048"/>
+          </a:xfrm>
+          <a:prstGeom prst="rect">
+            <a:avLst/>
+          </a:prstGeom>
+        </p:spPr>
+      </p:pic>
+      <p:pic>
+        <p:nvPicPr>
+          <p:cNvPr id="21" name="Picture 20" descr="bolt.png"/>
+          <p:cNvPicPr>
+            <a:picLocks noChangeAspect="1"/>
+          </p:cNvPicPr>
+          <p:nvPr/>
+        </p:nvPicPr>
+        <p:blipFill>
+          <a:blip r:embed="rId3"/>
+          <a:stretch>
+            <a:fillRect/>
+          </a:stretch>
+        </p:blipFill>
+        <p:spPr>
+          <a:xfrm>
+            <a:off x="6323308" y="1458656"/>
+            <a:ext cx="384048" cy="384048"/>
+          </a:xfrm>
+          <a:prstGeom prst="rect">
+            <a:avLst/>
+          </a:prstGeom>
+        </p:spPr>
+      </p:pic>
     </p:spTree>
   </p:cSld>
   <p:clrMapOvr>
@@ -12461,15 +12721,12 @@
         </p:nvSpPr>
         <p:spPr/>
         <p:txBody>
-          <a:bodyPr wrap="square"/>
+          <a:bodyPr wrap="square" tIns="822960"/>
           <a:lstStyle/>
           <a:p>
-            <a:r>
-              <a:rPr sz="2400"/>
-              <a:t>⚡  </a:t>
-            </a:r>
-            <a:r>
-              <a:rPr sz="1700" b="1">
+            <a:pPr algn="ctr"/>
+            <a:r>
+              <a:rPr sz="1600" b="1">
                 <a:solidFill>
                   <a:srgbClr val="1C4076"/>
                 </a:solidFill>
@@ -12478,8 +12735,9 @@
             </a:r>
           </a:p>
           <a:p>
-            <a:r>
-              <a:rPr sz="1300">
+            <a:pPr algn="ctr"/>
+            <a:r>
+              <a:rPr sz="1250">
                 <a:solidFill>
                   <a:srgbClr val="6B87A4"/>
                 </a:solidFill>
@@ -12501,15 +12759,12 @@
         </p:nvSpPr>
         <p:spPr/>
         <p:txBody>
-          <a:bodyPr wrap="square"/>
+          <a:bodyPr wrap="square" tIns="822960"/>
           <a:lstStyle/>
           <a:p>
-            <a:r>
-              <a:rPr sz="2400"/>
-              <a:t>🙌  </a:t>
-            </a:r>
-            <a:r>
-              <a:rPr sz="1700" b="1">
+            <a:pPr algn="ctr"/>
+            <a:r>
+              <a:rPr sz="1600" b="1">
                 <a:solidFill>
                   <a:srgbClr val="1C4076"/>
                 </a:solidFill>
@@ -12518,8 +12773,9 @@
             </a:r>
           </a:p>
           <a:p>
-            <a:r>
-              <a:rPr sz="1300">
+            <a:pPr algn="ctr"/>
+            <a:r>
+              <a:rPr sz="1250">
                 <a:solidFill>
                   <a:srgbClr val="6B87A4"/>
                 </a:solidFill>
@@ -12541,15 +12797,12 @@
         </p:nvSpPr>
         <p:spPr/>
         <p:txBody>
-          <a:bodyPr wrap="square"/>
+          <a:bodyPr wrap="square" tIns="822960"/>
           <a:lstStyle/>
           <a:p>
-            <a:r>
-              <a:rPr sz="2400"/>
-              <a:t>📌  </a:t>
-            </a:r>
-            <a:r>
-              <a:rPr sz="1700" b="1">
+            <a:pPr algn="ctr"/>
+            <a:r>
+              <a:rPr sz="1600" b="1">
                 <a:solidFill>
                   <a:srgbClr val="1C4076"/>
                 </a:solidFill>
@@ -12558,8 +12811,9 @@
             </a:r>
           </a:p>
           <a:p>
-            <a:r>
-              <a:rPr sz="1300">
+            <a:pPr algn="ctr"/>
+            <a:r>
+              <a:rPr sz="1250">
                 <a:solidFill>
                   <a:srgbClr val="6B87A4"/>
                 </a:solidFill>
@@ -12581,15 +12835,12 @@
         </p:nvSpPr>
         <p:spPr/>
         <p:txBody>
-          <a:bodyPr wrap="square"/>
+          <a:bodyPr wrap="square" tIns="822960"/>
           <a:lstStyle/>
           <a:p>
-            <a:r>
-              <a:rPr sz="2400"/>
-              <a:t>🛡️  </a:t>
-            </a:r>
-            <a:r>
-              <a:rPr sz="1700" b="1">
+            <a:pPr algn="ctr"/>
+            <a:r>
+              <a:rPr sz="1600" b="1">
                 <a:solidFill>
                   <a:srgbClr val="1C4076"/>
                 </a:solidFill>
@@ -12598,8 +12849,9 @@
             </a:r>
           </a:p>
           <a:p>
-            <a:r>
-              <a:rPr sz="1300">
+            <a:pPr algn="ctr"/>
+            <a:r>
+              <a:rPr sz="1250">
                 <a:solidFill>
                   <a:srgbClr val="6B87A4"/>
                 </a:solidFill>
@@ -12687,6 +12939,102 @@
           </a:p>
         </p:txBody>
       </p:sp>
+      <p:pic>
+        <p:nvPicPr>
+          <p:cNvPr id="8" name="Picture 7" descr="bolt.png"/>
+          <p:cNvPicPr>
+            <a:picLocks noChangeAspect="1"/>
+          </p:cNvPicPr>
+          <p:nvPr/>
+        </p:nvPicPr>
+        <p:blipFill>
+          <a:blip r:embed="rId2"/>
+          <a:stretch>
+            <a:fillRect/>
+          </a:stretch>
+        </p:blipFill>
+        <p:spPr>
+          <a:xfrm>
+            <a:off x="2898120" y="1467432"/>
+            <a:ext cx="585216" cy="585216"/>
+          </a:xfrm>
+          <a:prstGeom prst="rect">
+            <a:avLst/>
+          </a:prstGeom>
+        </p:spPr>
+      </p:pic>
+      <p:pic>
+        <p:nvPicPr>
+          <p:cNvPr id="9" name="Picture 8" descr="target.png"/>
+          <p:cNvPicPr>
+            <a:picLocks noChangeAspect="1"/>
+          </p:cNvPicPr>
+          <p:nvPr/>
+        </p:nvPicPr>
+        <p:blipFill>
+          <a:blip r:embed="rId3"/>
+          <a:stretch>
+            <a:fillRect/>
+          </a:stretch>
+        </p:blipFill>
+        <p:spPr>
+          <a:xfrm>
+            <a:off x="8687290" y="1467432"/>
+            <a:ext cx="585216" cy="585216"/>
+          </a:xfrm>
+          <a:prstGeom prst="rect">
+            <a:avLst/>
+          </a:prstGeom>
+        </p:spPr>
+      </p:pic>
+      <p:pic>
+        <p:nvPicPr>
+          <p:cNvPr id="10" name="Picture 9" descr="user.png"/>
+          <p:cNvPicPr>
+            <a:picLocks noChangeAspect="1"/>
+          </p:cNvPicPr>
+          <p:nvPr/>
+        </p:nvPicPr>
+        <p:blipFill>
+          <a:blip r:embed="rId4"/>
+          <a:stretch>
+            <a:fillRect/>
+          </a:stretch>
+        </p:blipFill>
+        <p:spPr>
+          <a:xfrm>
+            <a:off x="2908753" y="3987432"/>
+            <a:ext cx="585216" cy="585216"/>
+          </a:xfrm>
+          <a:prstGeom prst="rect">
+            <a:avLst/>
+          </a:prstGeom>
+        </p:spPr>
+      </p:pic>
+      <p:pic>
+        <p:nvPicPr>
+          <p:cNvPr id="11" name="Picture 10" descr="shield.png"/>
+          <p:cNvPicPr>
+            <a:picLocks noChangeAspect="1"/>
+          </p:cNvPicPr>
+          <p:nvPr/>
+        </p:nvPicPr>
+        <p:blipFill>
+          <a:blip r:embed="rId5"/>
+          <a:stretch>
+            <a:fillRect/>
+          </a:stretch>
+        </p:blipFill>
+        <p:spPr>
+          <a:xfrm>
+            <a:off x="8679451" y="3987432"/>
+            <a:ext cx="585216" cy="585216"/>
+          </a:xfrm>
+          <a:prstGeom prst="rect">
+            <a:avLst/>
+          </a:prstGeom>
+        </p:spPr>
+      </p:pic>
     </p:spTree>
   </p:cSld>
   <p:clrMapOvr>
@@ -12717,15 +13065,12 @@
         </p:nvSpPr>
         <p:spPr/>
         <p:txBody>
-          <a:bodyPr wrap="square"/>
+          <a:bodyPr wrap="square" tIns="822960"/>
           <a:lstStyle/>
           <a:p>
-            <a:r>
-              <a:rPr sz="2400"/>
-              <a:t>🔁  </a:t>
-            </a:r>
-            <a:r>
-              <a:rPr sz="1700" b="1">
+            <a:pPr algn="ctr"/>
+            <a:r>
+              <a:rPr sz="1600" b="1">
                 <a:solidFill>
                   <a:srgbClr val="1C4076"/>
                 </a:solidFill>
@@ -12734,8 +13079,9 @@
             </a:r>
           </a:p>
           <a:p>
-            <a:r>
-              <a:rPr sz="1300">
+            <a:pPr algn="ctr"/>
+            <a:r>
+              <a:rPr sz="1250">
                 <a:solidFill>
                   <a:srgbClr val="6B87A4"/>
                 </a:solidFill>
@@ -12757,15 +13103,12 @@
         </p:nvSpPr>
         <p:spPr/>
         <p:txBody>
-          <a:bodyPr wrap="square"/>
+          <a:bodyPr wrap="square" tIns="822960"/>
           <a:lstStyle/>
           <a:p>
-            <a:r>
-              <a:rPr sz="2400"/>
-              <a:t>🔔  </a:t>
-            </a:r>
-            <a:r>
-              <a:rPr sz="1700" b="1">
+            <a:pPr algn="ctr"/>
+            <a:r>
+              <a:rPr sz="1600" b="1">
                 <a:solidFill>
                   <a:srgbClr val="1C4076"/>
                 </a:solidFill>
@@ -12774,8 +13117,9 @@
             </a:r>
           </a:p>
           <a:p>
-            <a:r>
-              <a:rPr sz="1300">
+            <a:pPr algn="ctr"/>
+            <a:r>
+              <a:rPr sz="1250">
                 <a:solidFill>
                   <a:srgbClr val="6B87A4"/>
                 </a:solidFill>
@@ -12797,15 +13141,12 @@
         </p:nvSpPr>
         <p:spPr/>
         <p:txBody>
-          <a:bodyPr wrap="square"/>
+          <a:bodyPr wrap="square" tIns="822960"/>
           <a:lstStyle/>
           <a:p>
-            <a:r>
-              <a:rPr sz="2400"/>
-              <a:t>🔍  </a:t>
-            </a:r>
-            <a:r>
-              <a:rPr sz="1700" b="1">
+            <a:pPr algn="ctr"/>
+            <a:r>
+              <a:rPr sz="1600" b="1">
                 <a:solidFill>
                   <a:srgbClr val="1C4076"/>
                 </a:solidFill>
@@ -12814,8 +13155,9 @@
             </a:r>
           </a:p>
           <a:p>
-            <a:r>
-              <a:rPr sz="1300">
+            <a:pPr algn="ctr"/>
+            <a:r>
+              <a:rPr sz="1250">
                 <a:solidFill>
                   <a:srgbClr val="6B87A4"/>
                 </a:solidFill>
@@ -12837,15 +13179,12 @@
         </p:nvSpPr>
         <p:spPr/>
         <p:txBody>
-          <a:bodyPr wrap="square"/>
+          <a:bodyPr wrap="square" tIns="822960"/>
           <a:lstStyle/>
           <a:p>
-            <a:r>
-              <a:rPr sz="2400"/>
-              <a:t>📊  </a:t>
-            </a:r>
-            <a:r>
-              <a:rPr sz="1700" b="1">
+            <a:pPr algn="ctr"/>
+            <a:r>
+              <a:rPr sz="1600" b="1">
                 <a:solidFill>
                   <a:srgbClr val="1C4076"/>
                 </a:solidFill>
@@ -12854,8 +13193,9 @@
             </a:r>
           </a:p>
           <a:p>
-            <a:r>
-              <a:rPr sz="1300">
+            <a:pPr algn="ctr"/>
+            <a:r>
+              <a:rPr sz="1250">
                 <a:solidFill>
                   <a:srgbClr val="6B87A4"/>
                 </a:solidFill>
@@ -12943,6 +13283,102 @@
           </a:p>
         </p:txBody>
       </p:sp>
+      <p:pic>
+        <p:nvPicPr>
+          <p:cNvPr id="8" name="Picture 7" descr="refresh.png"/>
+          <p:cNvPicPr>
+            <a:picLocks noChangeAspect="1"/>
+          </p:cNvPicPr>
+          <p:nvPr/>
+        </p:nvPicPr>
+        <p:blipFill>
+          <a:blip r:embed="rId2"/>
+          <a:stretch>
+            <a:fillRect/>
+          </a:stretch>
+        </p:blipFill>
+        <p:spPr>
+          <a:xfrm>
+            <a:off x="2898120" y="1467432"/>
+            <a:ext cx="585216" cy="585216"/>
+          </a:xfrm>
+          <a:prstGeom prst="rect">
+            <a:avLst/>
+          </a:prstGeom>
+        </p:spPr>
+      </p:pic>
+      <p:pic>
+        <p:nvPicPr>
+          <p:cNvPr id="9" name="Picture 8" descr="search.png"/>
+          <p:cNvPicPr>
+            <a:picLocks noChangeAspect="1"/>
+          </p:cNvPicPr>
+          <p:nvPr/>
+        </p:nvPicPr>
+        <p:blipFill>
+          <a:blip r:embed="rId3"/>
+          <a:stretch>
+            <a:fillRect/>
+          </a:stretch>
+        </p:blipFill>
+        <p:spPr>
+          <a:xfrm>
+            <a:off x="8687290" y="1467432"/>
+            <a:ext cx="585216" cy="585216"/>
+          </a:xfrm>
+          <a:prstGeom prst="rect">
+            <a:avLst/>
+          </a:prstGeom>
+        </p:spPr>
+      </p:pic>
+      <p:pic>
+        <p:nvPicPr>
+          <p:cNvPr id="10" name="Picture 9" descr="bell.png"/>
+          <p:cNvPicPr>
+            <a:picLocks noChangeAspect="1"/>
+          </p:cNvPicPr>
+          <p:nvPr/>
+        </p:nvPicPr>
+        <p:blipFill>
+          <a:blip r:embed="rId4"/>
+          <a:stretch>
+            <a:fillRect/>
+          </a:stretch>
+        </p:blipFill>
+        <p:spPr>
+          <a:xfrm>
+            <a:off x="2908753" y="3987432"/>
+            <a:ext cx="585216" cy="585216"/>
+          </a:xfrm>
+          <a:prstGeom prst="rect">
+            <a:avLst/>
+          </a:prstGeom>
+        </p:spPr>
+      </p:pic>
+      <p:pic>
+        <p:nvPicPr>
+          <p:cNvPr id="11" name="Picture 10" descr="chart.png"/>
+          <p:cNvPicPr>
+            <a:picLocks noChangeAspect="1"/>
+          </p:cNvPicPr>
+          <p:nvPr/>
+        </p:nvPicPr>
+        <p:blipFill>
+          <a:blip r:embed="rId5"/>
+          <a:stretch>
+            <a:fillRect/>
+          </a:stretch>
+        </p:blipFill>
+        <p:spPr>
+          <a:xfrm>
+            <a:off x="8679451" y="3987432"/>
+            <a:ext cx="585216" cy="585216"/>
+          </a:xfrm>
+          <a:prstGeom prst="rect">
+            <a:avLst/>
+          </a:prstGeom>
+        </p:spPr>
+      </p:pic>
     </p:spTree>
   </p:cSld>
   <p:clrMapOvr>

</xml_diff>